<commit_message>
fix: rebuild score/quality pptx as editable native shapes, not embedded images
</commit_message>
<xml_diff>
--- a/analysis/quality-grid.pptx
+++ b/analysis/quality-grid.pptx
@@ -7,7 +7,7 @@
   <p:sldIdLst>
     <p:sldId id="256" r:id="rId7"/>
   </p:sldIdLst>
-  <p:sldSz cx="12192000" cy="6858000" type="screen4x3"/>
+  <p:sldSz cx="12191695" cy="6858000" type="screen4x3"/>
   <p:notesSz cx="6858000" cy="9144000"/>
   <p:defaultTextStyle>
     <a:defPPr>
@@ -3088,30 +3088,3238 @@
         <p:nvPr/>
       </p:nvGrpSpPr>
       <p:grpSpPr/>
-      <p:pic>
-        <p:nvPicPr>
-          <p:cNvPr id="2" name="Picture 1" descr="quality-slide.png"/>
-          <p:cNvPicPr>
-            <a:picLocks noChangeAspect="1"/>
-          </p:cNvPicPr>
-          <p:nvPr/>
-        </p:nvPicPr>
-        <p:blipFill>
-          <a:blip r:embed="rId2"/>
-          <a:stretch>
-            <a:fillRect/>
-          </a:stretch>
-        </p:blipFill>
+      <p:sp>
+        <p:nvSpPr>
+          <p:cNvPr id="2" name="Rectangle 1"/>
+          <p:cNvSpPr/>
+          <p:nvPr/>
+        </p:nvSpPr>
         <p:spPr>
           <a:xfrm>
             <a:off x="0" y="0"/>
-            <a:ext cx="12192000" cy="6858000"/>
+            <a:ext cx="12191695" cy="6858000"/>
           </a:xfrm>
           <a:prstGeom prst="rect">
             <a:avLst/>
           </a:prstGeom>
-        </p:spPr>
-      </p:pic>
+          <a:solidFill>
+            <a:srgbClr val="0D0D13"/>
+          </a:solidFill>
+          <a:ln>
+            <a:noFill/>
+          </a:ln>
+          <a:effectLst/>
+        </p:spPr>
+        <p:style>
+          <a:lnRef idx="1">
+            <a:schemeClr val="accent1"/>
+          </a:lnRef>
+          <a:fillRef idx="3">
+            <a:schemeClr val="accent1"/>
+          </a:fillRef>
+          <a:effectRef idx="2">
+            <a:schemeClr val="accent1"/>
+          </a:effectRef>
+          <a:fontRef idx="minor">
+            <a:schemeClr val="lt1"/>
+          </a:fontRef>
+        </p:style>
+        <p:txBody>
+          <a:bodyPr rtlCol="0" anchor="ctr"/>
+          <a:lstStyle/>
+          <a:p>
+            <a:pPr algn="ctr"/>
+          </a:p>
+        </p:txBody>
+      </p:sp>
+      <p:sp>
+        <p:nvSpPr>
+          <p:cNvPr id="3" name="TextBox 2"/>
+          <p:cNvSpPr txBox="1"/>
+          <p:nvPr/>
+        </p:nvSpPr>
+        <p:spPr>
+          <a:xfrm>
+            <a:off x="658368" y="457200"/>
+            <a:ext cx="8229600" cy="274320"/>
+          </a:xfrm>
+          <a:prstGeom prst="rect">
+            <a:avLst/>
+          </a:prstGeom>
+          <a:noFill/>
+        </p:spPr>
+        <p:txBody>
+          <a:bodyPr wrap="square" anchor="t" lIns="0" rIns="0" tIns="0" bIns="0">
+            <a:spAutoFit/>
+          </a:bodyPr>
+          <a:lstStyle/>
+          <a:p>
+            <a:pPr algn="l"/>
+            <a:r>
+              <a:rPr sz="1200" b="1" i="0" spc="140">
+                <a:solidFill>
+                  <a:srgbClr val="6F6D66"/>
+                </a:solidFill>
+                <a:latin typeface="Inter"/>
+              </a:rPr>
+              <a:t>4D TIC-TAC-TOE · AGENT BENCHMARK</a:t>
+            </a:r>
+          </a:p>
+        </p:txBody>
+      </p:sp>
+      <p:sp>
+        <p:nvSpPr>
+          <p:cNvPr id="4" name="TextBox 3"/>
+          <p:cNvSpPr txBox="1"/>
+          <p:nvPr/>
+        </p:nvSpPr>
+        <p:spPr>
+          <a:xfrm>
+            <a:off x="658368" y="713232"/>
+            <a:ext cx="9144000" cy="502920"/>
+          </a:xfrm>
+          <a:prstGeom prst="rect">
+            <a:avLst/>
+          </a:prstGeom>
+          <a:noFill/>
+        </p:spPr>
+        <p:txBody>
+          <a:bodyPr wrap="square" anchor="t" lIns="0" rIns="0" tIns="0" bIns="0">
+            <a:spAutoFit/>
+          </a:bodyPr>
+          <a:lstStyle/>
+          <a:p>
+            <a:pPr algn="l"/>
+            <a:r>
+              <a:rPr sz="3400" b="1" i="0">
+                <a:solidFill>
+                  <a:srgbClr val="E8E6E1"/>
+                </a:solidFill>
+                <a:latin typeface="Inter"/>
+              </a:rPr>
+              <a:t>Code quality, 0–10</a:t>
+            </a:r>
+          </a:p>
+        </p:txBody>
+      </p:sp>
+      <p:sp>
+        <p:nvSpPr>
+          <p:cNvPr id="5" name="TextBox 4"/>
+          <p:cNvSpPr txBox="1"/>
+          <p:nvPr/>
+        </p:nvSpPr>
+        <p:spPr>
+          <a:xfrm>
+            <a:off x="658368" y="1298448"/>
+            <a:ext cx="10874959" cy="777240"/>
+          </a:xfrm>
+          <a:prstGeom prst="rect">
+            <a:avLst/>
+          </a:prstGeom>
+          <a:noFill/>
+        </p:spPr>
+        <p:txBody>
+          <a:bodyPr wrap="square" anchor="t" lIns="0" rIns="0" tIns="0" bIns="0">
+            <a:spAutoFit/>
+          </a:bodyPr>
+          <a:lstStyle/>
+          <a:p>
+            <a:pPr algn="l"/>
+            <a:r>
+              <a:rPr sz="1250" b="0" i="0">
+                <a:solidFill>
+                  <a:srgbClr val="C9C6BF"/>
+                </a:solidFill>
+                <a:latin typeface="Inter"/>
+              </a:rPr>
+              <a:t>Independent review of each working codebase: correctness, architecture, test quality, and completeness against TASK.md. No cost or speed in this number, purely how good the code is. Fixed 0-10 scale, not rescaled per column, so the color tells you the real spread.</a:t>
+            </a:r>
+          </a:p>
+        </p:txBody>
+      </p:sp>
+      <p:sp>
+        <p:nvSpPr>
+          <p:cNvPr id="6" name="TextBox 5"/>
+          <p:cNvSpPr txBox="1"/>
+          <p:nvPr/>
+        </p:nvSpPr>
+        <p:spPr>
+          <a:xfrm>
+            <a:off x="1956816" y="2148840"/>
+            <a:ext cx="2394127" cy="292608"/>
+          </a:xfrm>
+          <a:prstGeom prst="rect">
+            <a:avLst/>
+          </a:prstGeom>
+          <a:noFill/>
+        </p:spPr>
+        <p:txBody>
+          <a:bodyPr wrap="square" anchor="b" lIns="0" rIns="0" tIns="0" bIns="0">
+            <a:spAutoFit/>
+          </a:bodyPr>
+          <a:lstStyle/>
+          <a:p>
+            <a:pPr algn="ctr"/>
+            <a:r>
+              <a:rPr sz="1050" b="1" i="0" spc="80">
+                <a:solidFill>
+                  <a:srgbClr val="6F6D66"/>
+                </a:solidFill>
+                <a:latin typeface="Inter"/>
+              </a:rPr>
+              <a:t>CLAUDE-CODE</a:t>
+            </a:r>
+          </a:p>
+        </p:txBody>
+      </p:sp>
+      <p:sp>
+        <p:nvSpPr>
+          <p:cNvPr id="7" name="TextBox 6"/>
+          <p:cNvSpPr txBox="1"/>
+          <p:nvPr/>
+        </p:nvSpPr>
+        <p:spPr>
+          <a:xfrm>
+            <a:off x="4382947" y="2148840"/>
+            <a:ext cx="2394127" cy="292608"/>
+          </a:xfrm>
+          <a:prstGeom prst="rect">
+            <a:avLst/>
+          </a:prstGeom>
+          <a:noFill/>
+        </p:spPr>
+        <p:txBody>
+          <a:bodyPr wrap="square" anchor="b" lIns="0" rIns="0" tIns="0" bIns="0">
+            <a:spAutoFit/>
+          </a:bodyPr>
+          <a:lstStyle/>
+          <a:p>
+            <a:pPr algn="ctr"/>
+            <a:r>
+              <a:rPr sz="1050" b="1" i="0" spc="80">
+                <a:solidFill>
+                  <a:srgbClr val="6F6D66"/>
+                </a:solidFill>
+                <a:latin typeface="Inter"/>
+              </a:rPr>
+              <a:t>OMH</a:t>
+            </a:r>
+          </a:p>
+        </p:txBody>
+      </p:sp>
+      <p:sp>
+        <p:nvSpPr>
+          <p:cNvPr id="8" name="TextBox 7"/>
+          <p:cNvSpPr txBox="1"/>
+          <p:nvPr/>
+        </p:nvSpPr>
+        <p:spPr>
+          <a:xfrm>
+            <a:off x="6809078" y="2148840"/>
+            <a:ext cx="2394127" cy="292608"/>
+          </a:xfrm>
+          <a:prstGeom prst="rect">
+            <a:avLst/>
+          </a:prstGeom>
+          <a:noFill/>
+        </p:spPr>
+        <p:txBody>
+          <a:bodyPr wrap="square" anchor="b" lIns="0" rIns="0" tIns="0" bIns="0">
+            <a:spAutoFit/>
+          </a:bodyPr>
+          <a:lstStyle/>
+          <a:p>
+            <a:pPr algn="ctr"/>
+            <a:r>
+              <a:rPr sz="1050" b="1" i="0" spc="80">
+                <a:solidFill>
+                  <a:srgbClr val="6F6D66"/>
+                </a:solidFill>
+                <a:latin typeface="Inter"/>
+              </a:rPr>
+              <a:t>OPENCODE</a:t>
+            </a:r>
+          </a:p>
+        </p:txBody>
+      </p:sp>
+      <p:sp>
+        <p:nvSpPr>
+          <p:cNvPr id="9" name="TextBox 8"/>
+          <p:cNvSpPr txBox="1"/>
+          <p:nvPr/>
+        </p:nvSpPr>
+        <p:spPr>
+          <a:xfrm>
+            <a:off x="9235209" y="2148840"/>
+            <a:ext cx="2394127" cy="292608"/>
+          </a:xfrm>
+          <a:prstGeom prst="rect">
+            <a:avLst/>
+          </a:prstGeom>
+          <a:noFill/>
+        </p:spPr>
+        <p:txBody>
+          <a:bodyPr wrap="square" anchor="b" lIns="0" rIns="0" tIns="0" bIns="0">
+            <a:spAutoFit/>
+          </a:bodyPr>
+          <a:lstStyle/>
+          <a:p>
+            <a:pPr algn="ctr"/>
+            <a:r>
+              <a:rPr sz="1050" b="1" i="0" spc="80">
+                <a:solidFill>
+                  <a:srgbClr val="6F6D66"/>
+                </a:solidFill>
+                <a:latin typeface="Inter"/>
+              </a:rPr>
+              <a:t>AIDER</a:t>
+            </a:r>
+          </a:p>
+        </p:txBody>
+      </p:sp>
+      <p:sp>
+        <p:nvSpPr>
+          <p:cNvPr id="10" name="TextBox 9"/>
+          <p:cNvSpPr txBox="1"/>
+          <p:nvPr/>
+        </p:nvSpPr>
+        <p:spPr>
+          <a:xfrm>
+            <a:off x="658368" y="2496312"/>
+            <a:ext cx="1207008" cy="382219"/>
+          </a:xfrm>
+          <a:prstGeom prst="rect">
+            <a:avLst/>
+          </a:prstGeom>
+          <a:noFill/>
+        </p:spPr>
+        <p:txBody>
+          <a:bodyPr wrap="square" anchor="ctr" lIns="0" rIns="0" tIns="0" bIns="0">
+            <a:spAutoFit/>
+          </a:bodyPr>
+          <a:lstStyle/>
+          <a:p>
+            <a:pPr algn="r"/>
+            <a:r>
+              <a:rPr sz="1150" b="1" i="0">
+                <a:solidFill>
+                  <a:srgbClr val="C9C6BF"/>
+                </a:solidFill>
+                <a:latin typeface="Inter"/>
+              </a:rPr>
+              <a:t>Opus 5</a:t>
+            </a:r>
+          </a:p>
+        </p:txBody>
+      </p:sp>
+      <p:sp>
+        <p:nvSpPr>
+          <p:cNvPr id="11" name="Rounded Rectangle 10"/>
+          <p:cNvSpPr/>
+          <p:nvPr/>
+        </p:nvSpPr>
+        <p:spPr>
+          <a:xfrm>
+            <a:off x="1956816" y="2496312"/>
+            <a:ext cx="2394127" cy="382219"/>
+          </a:xfrm>
+          <a:prstGeom prst="roundRect">
+            <a:avLst>
+              <a:gd name="adj" fmla="val 6000"/>
+            </a:avLst>
+          </a:prstGeom>
+          <a:solidFill>
+            <a:srgbClr val="DE9FA9"/>
+          </a:solidFill>
+          <a:ln>
+            <a:noFill/>
+          </a:ln>
+          <a:effectLst/>
+        </p:spPr>
+        <p:style>
+          <a:lnRef idx="1">
+            <a:schemeClr val="accent1"/>
+          </a:lnRef>
+          <a:fillRef idx="3">
+            <a:schemeClr val="accent1"/>
+          </a:fillRef>
+          <a:effectRef idx="2">
+            <a:schemeClr val="accent1"/>
+          </a:effectRef>
+          <a:fontRef idx="minor">
+            <a:schemeClr val="lt1"/>
+          </a:fontRef>
+        </p:style>
+        <p:txBody>
+          <a:bodyPr rtlCol="0" anchor="ctr" wrap="square" lIns="25400" rIns="25400" tIns="25400" bIns="25400"/>
+          <a:lstStyle/>
+          <a:p>
+            <a:pPr algn="ctr"/>
+            <a:r>
+              <a:rPr sz="1500" b="1">
+                <a:solidFill>
+                  <a:srgbClr val="08080C"/>
+                </a:solidFill>
+                <a:latin typeface="JetBrains Mono"/>
+              </a:rPr>
+              <a:t>9.0</a:t>
+            </a:r>
+          </a:p>
+        </p:txBody>
+      </p:sp>
+      <p:sp>
+        <p:nvSpPr>
+          <p:cNvPr id="12" name="Rounded Rectangle 11"/>
+          <p:cNvSpPr/>
+          <p:nvPr/>
+        </p:nvSpPr>
+        <p:spPr>
+          <a:xfrm>
+            <a:off x="4382947" y="2496312"/>
+            <a:ext cx="2394127" cy="382219"/>
+          </a:xfrm>
+          <a:prstGeom prst="roundRect">
+            <a:avLst>
+              <a:gd name="adj" fmla="val 6000"/>
+            </a:avLst>
+          </a:prstGeom>
+          <a:solidFill>
+            <a:srgbClr val="EFBBC3"/>
+          </a:solidFill>
+          <a:ln>
+            <a:noFill/>
+          </a:ln>
+          <a:effectLst/>
+        </p:spPr>
+        <p:style>
+          <a:lnRef idx="1">
+            <a:schemeClr val="accent1"/>
+          </a:lnRef>
+          <a:fillRef idx="3">
+            <a:schemeClr val="accent1"/>
+          </a:fillRef>
+          <a:effectRef idx="2">
+            <a:schemeClr val="accent1"/>
+          </a:effectRef>
+          <a:fontRef idx="minor">
+            <a:schemeClr val="lt1"/>
+          </a:fontRef>
+        </p:style>
+        <p:txBody>
+          <a:bodyPr rtlCol="0" anchor="ctr" wrap="square" lIns="25400" rIns="25400" tIns="25400" bIns="25400"/>
+          <a:lstStyle/>
+          <a:p>
+            <a:pPr algn="ctr"/>
+            <a:r>
+              <a:rPr sz="1500" b="1">
+                <a:solidFill>
+                  <a:srgbClr val="08080C"/>
+                </a:solidFill>
+                <a:latin typeface="JetBrains Mono"/>
+              </a:rPr>
+              <a:t>9.8</a:t>
+            </a:r>
+          </a:p>
+        </p:txBody>
+      </p:sp>
+      <p:sp>
+        <p:nvSpPr>
+          <p:cNvPr id="13" name="Rounded Rectangle 12"/>
+          <p:cNvSpPr/>
+          <p:nvPr/>
+        </p:nvSpPr>
+        <p:spPr>
+          <a:xfrm>
+            <a:off x="6809078" y="2496312"/>
+            <a:ext cx="2394127" cy="382219"/>
+          </a:xfrm>
+          <a:prstGeom prst="roundRect">
+            <a:avLst>
+              <a:gd name="adj" fmla="val 6000"/>
+            </a:avLst>
+          </a:prstGeom>
+          <a:solidFill>
+            <a:srgbClr val="C97C88"/>
+          </a:solidFill>
+          <a:ln>
+            <a:noFill/>
+          </a:ln>
+          <a:effectLst/>
+        </p:spPr>
+        <p:style>
+          <a:lnRef idx="1">
+            <a:schemeClr val="accent1"/>
+          </a:lnRef>
+          <a:fillRef idx="3">
+            <a:schemeClr val="accent1"/>
+          </a:fillRef>
+          <a:effectRef idx="2">
+            <a:schemeClr val="accent1"/>
+          </a:effectRef>
+          <a:fontRef idx="minor">
+            <a:schemeClr val="lt1"/>
+          </a:fontRef>
+        </p:style>
+        <p:txBody>
+          <a:bodyPr rtlCol="0" anchor="ctr" wrap="square" lIns="25400" rIns="25400" tIns="25400" bIns="25400"/>
+          <a:lstStyle/>
+          <a:p>
+            <a:pPr algn="ctr"/>
+            <a:r>
+              <a:rPr sz="1500" b="1">
+                <a:solidFill>
+                  <a:srgbClr val="08080C"/>
+                </a:solidFill>
+                <a:latin typeface="JetBrains Mono"/>
+              </a:rPr>
+              <a:t>8.0</a:t>
+            </a:r>
+          </a:p>
+        </p:txBody>
+      </p:sp>
+      <p:sp>
+        <p:nvSpPr>
+          <p:cNvPr id="14" name="Rounded Rectangle 13"/>
+          <p:cNvSpPr/>
+          <p:nvPr/>
+        </p:nvSpPr>
+        <p:spPr>
+          <a:xfrm>
+            <a:off x="9235209" y="2496312"/>
+            <a:ext cx="2394127" cy="382219"/>
+          </a:xfrm>
+          <a:prstGeom prst="roundRect">
+            <a:avLst>
+              <a:gd name="adj" fmla="val 6000"/>
+            </a:avLst>
+          </a:prstGeom>
+          <a:solidFill>
+            <a:srgbClr val="3A1520"/>
+          </a:solidFill>
+          <a:ln>
+            <a:noFill/>
+          </a:ln>
+          <a:effectLst/>
+        </p:spPr>
+        <p:style>
+          <a:lnRef idx="1">
+            <a:schemeClr val="accent1"/>
+          </a:lnRef>
+          <a:fillRef idx="3">
+            <a:schemeClr val="accent1"/>
+          </a:fillRef>
+          <a:effectRef idx="2">
+            <a:schemeClr val="accent1"/>
+          </a:effectRef>
+          <a:fontRef idx="minor">
+            <a:schemeClr val="lt1"/>
+          </a:fontRef>
+        </p:style>
+        <p:txBody>
+          <a:bodyPr rtlCol="0" anchor="ctr" wrap="square" lIns="25400" rIns="25400" tIns="25400" bIns="25400"/>
+          <a:lstStyle/>
+          <a:p>
+            <a:pPr algn="ctr"/>
+            <a:r>
+              <a:rPr sz="1500" b="1">
+                <a:solidFill>
+                  <a:srgbClr val="F56B8C"/>
+                </a:solidFill>
+                <a:latin typeface="Inter"/>
+              </a:rPr>
+              <a:t>×</a:t>
+            </a:r>
+          </a:p>
+        </p:txBody>
+      </p:sp>
+      <p:sp>
+        <p:nvSpPr>
+          <p:cNvPr id="15" name="TextBox 14"/>
+          <p:cNvSpPr txBox="1"/>
+          <p:nvPr/>
+        </p:nvSpPr>
+        <p:spPr>
+          <a:xfrm>
+            <a:off x="658368" y="2910535"/>
+            <a:ext cx="1207008" cy="382219"/>
+          </a:xfrm>
+          <a:prstGeom prst="rect">
+            <a:avLst/>
+          </a:prstGeom>
+          <a:noFill/>
+        </p:spPr>
+        <p:txBody>
+          <a:bodyPr wrap="square" anchor="ctr" lIns="0" rIns="0" tIns="0" bIns="0">
+            <a:spAutoFit/>
+          </a:bodyPr>
+          <a:lstStyle/>
+          <a:p>
+            <a:pPr algn="r"/>
+            <a:r>
+              <a:rPr sz="1150" b="1" i="0">
+                <a:solidFill>
+                  <a:srgbClr val="C9C6BF"/>
+                </a:solidFill>
+                <a:latin typeface="Inter"/>
+              </a:rPr>
+              <a:t>Sonnet 5</a:t>
+            </a:r>
+          </a:p>
+        </p:txBody>
+      </p:sp>
+      <p:sp>
+        <p:nvSpPr>
+          <p:cNvPr id="16" name="Rounded Rectangle 15"/>
+          <p:cNvSpPr/>
+          <p:nvPr/>
+        </p:nvSpPr>
+        <p:spPr>
+          <a:xfrm>
+            <a:off x="1956816" y="2910535"/>
+            <a:ext cx="2394127" cy="382219"/>
+          </a:xfrm>
+          <a:prstGeom prst="roundRect">
+            <a:avLst>
+              <a:gd name="adj" fmla="val 6000"/>
+            </a:avLst>
+          </a:prstGeom>
+          <a:solidFill>
+            <a:srgbClr val="DA98A2"/>
+          </a:solidFill>
+          <a:ln>
+            <a:noFill/>
+          </a:ln>
+          <a:effectLst/>
+        </p:spPr>
+        <p:style>
+          <a:lnRef idx="1">
+            <a:schemeClr val="accent1"/>
+          </a:lnRef>
+          <a:fillRef idx="3">
+            <a:schemeClr val="accent1"/>
+          </a:fillRef>
+          <a:effectRef idx="2">
+            <a:schemeClr val="accent1"/>
+          </a:effectRef>
+          <a:fontRef idx="minor">
+            <a:schemeClr val="lt1"/>
+          </a:fontRef>
+        </p:style>
+        <p:txBody>
+          <a:bodyPr rtlCol="0" anchor="ctr" wrap="square" lIns="25400" rIns="25400" tIns="25400" bIns="25400"/>
+          <a:lstStyle/>
+          <a:p>
+            <a:pPr algn="ctr"/>
+            <a:r>
+              <a:rPr sz="1500" b="1">
+                <a:solidFill>
+                  <a:srgbClr val="08080C"/>
+                </a:solidFill>
+                <a:latin typeface="JetBrains Mono"/>
+              </a:rPr>
+              <a:t>8.8</a:t>
+            </a:r>
+          </a:p>
+        </p:txBody>
+      </p:sp>
+      <p:sp>
+        <p:nvSpPr>
+          <p:cNvPr id="17" name="Rounded Rectangle 16"/>
+          <p:cNvSpPr/>
+          <p:nvPr/>
+        </p:nvSpPr>
+        <p:spPr>
+          <a:xfrm>
+            <a:off x="4382947" y="2910535"/>
+            <a:ext cx="2394127" cy="382219"/>
+          </a:xfrm>
+          <a:prstGeom prst="roundRect">
+            <a:avLst>
+              <a:gd name="adj" fmla="val 6000"/>
+            </a:avLst>
+          </a:prstGeom>
+          <a:solidFill>
+            <a:srgbClr val="E4A9B3"/>
+          </a:solidFill>
+          <a:ln>
+            <a:noFill/>
+          </a:ln>
+          <a:effectLst/>
+        </p:spPr>
+        <p:style>
+          <a:lnRef idx="1">
+            <a:schemeClr val="accent1"/>
+          </a:lnRef>
+          <a:fillRef idx="3">
+            <a:schemeClr val="accent1"/>
+          </a:fillRef>
+          <a:effectRef idx="2">
+            <a:schemeClr val="accent1"/>
+          </a:effectRef>
+          <a:fontRef idx="minor">
+            <a:schemeClr val="lt1"/>
+          </a:fontRef>
+        </p:style>
+        <p:txBody>
+          <a:bodyPr rtlCol="0" anchor="ctr" wrap="square" lIns="25400" rIns="25400" tIns="25400" bIns="25400"/>
+          <a:lstStyle/>
+          <a:p>
+            <a:pPr algn="ctr"/>
+            <a:r>
+              <a:rPr sz="1500" b="1">
+                <a:solidFill>
+                  <a:srgbClr val="08080C"/>
+                </a:solidFill>
+                <a:latin typeface="JetBrains Mono"/>
+              </a:rPr>
+              <a:t>9.3</a:t>
+            </a:r>
+          </a:p>
+        </p:txBody>
+      </p:sp>
+      <p:sp>
+        <p:nvSpPr>
+          <p:cNvPr id="18" name="Rounded Rectangle 17"/>
+          <p:cNvSpPr/>
+          <p:nvPr/>
+        </p:nvSpPr>
+        <p:spPr>
+          <a:xfrm>
+            <a:off x="6809078" y="2910535"/>
+            <a:ext cx="2394127" cy="382219"/>
+          </a:xfrm>
+          <a:prstGeom prst="roundRect">
+            <a:avLst>
+              <a:gd name="adj" fmla="val 6000"/>
+            </a:avLst>
+          </a:prstGeom>
+          <a:solidFill>
+            <a:srgbClr val="DA98A2"/>
+          </a:solidFill>
+          <a:ln>
+            <a:noFill/>
+          </a:ln>
+          <a:effectLst/>
+        </p:spPr>
+        <p:style>
+          <a:lnRef idx="1">
+            <a:schemeClr val="accent1"/>
+          </a:lnRef>
+          <a:fillRef idx="3">
+            <a:schemeClr val="accent1"/>
+          </a:fillRef>
+          <a:effectRef idx="2">
+            <a:schemeClr val="accent1"/>
+          </a:effectRef>
+          <a:fontRef idx="minor">
+            <a:schemeClr val="lt1"/>
+          </a:fontRef>
+        </p:style>
+        <p:txBody>
+          <a:bodyPr rtlCol="0" anchor="ctr" wrap="square" lIns="25400" rIns="25400" tIns="25400" bIns="25400"/>
+          <a:lstStyle/>
+          <a:p>
+            <a:pPr algn="ctr"/>
+            <a:r>
+              <a:rPr sz="1500" b="1">
+                <a:solidFill>
+                  <a:srgbClr val="08080C"/>
+                </a:solidFill>
+                <a:latin typeface="JetBrains Mono"/>
+              </a:rPr>
+              <a:t>8.8</a:t>
+            </a:r>
+          </a:p>
+        </p:txBody>
+      </p:sp>
+      <p:sp>
+        <p:nvSpPr>
+          <p:cNvPr id="19" name="Rounded Rectangle 18"/>
+          <p:cNvSpPr/>
+          <p:nvPr/>
+        </p:nvSpPr>
+        <p:spPr>
+          <a:xfrm>
+            <a:off x="9235209" y="2910535"/>
+            <a:ext cx="2394127" cy="382219"/>
+          </a:xfrm>
+          <a:prstGeom prst="roundRect">
+            <a:avLst>
+              <a:gd name="adj" fmla="val 6000"/>
+            </a:avLst>
+          </a:prstGeom>
+          <a:solidFill>
+            <a:srgbClr val="BA6370"/>
+          </a:solidFill>
+          <a:ln>
+            <a:noFill/>
+          </a:ln>
+          <a:effectLst/>
+        </p:spPr>
+        <p:style>
+          <a:lnRef idx="1">
+            <a:schemeClr val="accent1"/>
+          </a:lnRef>
+          <a:fillRef idx="3">
+            <a:schemeClr val="accent1"/>
+          </a:fillRef>
+          <a:effectRef idx="2">
+            <a:schemeClr val="accent1"/>
+          </a:effectRef>
+          <a:fontRef idx="minor">
+            <a:schemeClr val="lt1"/>
+          </a:fontRef>
+        </p:style>
+        <p:txBody>
+          <a:bodyPr rtlCol="0" anchor="ctr" wrap="square" lIns="25400" rIns="25400" tIns="25400" bIns="25400"/>
+          <a:lstStyle/>
+          <a:p>
+            <a:pPr algn="ctr"/>
+            <a:r>
+              <a:rPr sz="1500" b="1">
+                <a:solidFill>
+                  <a:srgbClr val="08080C"/>
+                </a:solidFill>
+                <a:latin typeface="JetBrains Mono"/>
+              </a:rPr>
+              <a:t>7.3</a:t>
+            </a:r>
+          </a:p>
+        </p:txBody>
+      </p:sp>
+      <p:sp>
+        <p:nvSpPr>
+          <p:cNvPr id="20" name="TextBox 19"/>
+          <p:cNvSpPr txBox="1"/>
+          <p:nvPr/>
+        </p:nvSpPr>
+        <p:spPr>
+          <a:xfrm>
+            <a:off x="658368" y="3324758"/>
+            <a:ext cx="1207008" cy="382219"/>
+          </a:xfrm>
+          <a:prstGeom prst="rect">
+            <a:avLst/>
+          </a:prstGeom>
+          <a:noFill/>
+        </p:spPr>
+        <p:txBody>
+          <a:bodyPr wrap="square" anchor="ctr" lIns="0" rIns="0" tIns="0" bIns="0">
+            <a:spAutoFit/>
+          </a:bodyPr>
+          <a:lstStyle/>
+          <a:p>
+            <a:pPr algn="r"/>
+            <a:r>
+              <a:rPr sz="1150" b="1" i="0">
+                <a:solidFill>
+                  <a:srgbClr val="C9C6BF"/>
+                </a:solidFill>
+                <a:latin typeface="Inter"/>
+              </a:rPr>
+              <a:t>Fable 5</a:t>
+            </a:r>
+          </a:p>
+        </p:txBody>
+      </p:sp>
+      <p:sp>
+        <p:nvSpPr>
+          <p:cNvPr id="21" name="Rounded Rectangle 20"/>
+          <p:cNvSpPr/>
+          <p:nvPr/>
+        </p:nvSpPr>
+        <p:spPr>
+          <a:xfrm>
+            <a:off x="1956816" y="3324758"/>
+            <a:ext cx="2394127" cy="382219"/>
+          </a:xfrm>
+          <a:prstGeom prst="roundRect">
+            <a:avLst>
+              <a:gd name="adj" fmla="val 6000"/>
+            </a:avLst>
+          </a:prstGeom>
+          <a:noFill/>
+          <a:ln w="9525">
+            <a:solidFill>
+              <a:srgbClr val="3A3A48"/>
+            </a:solidFill>
+            <a:prstDash val="dash"/>
+          </a:ln>
+          <a:effectLst/>
+        </p:spPr>
+        <p:style>
+          <a:lnRef idx="1">
+            <a:schemeClr val="accent1"/>
+          </a:lnRef>
+          <a:fillRef idx="3">
+            <a:schemeClr val="accent1"/>
+          </a:fillRef>
+          <a:effectRef idx="2">
+            <a:schemeClr val="accent1"/>
+          </a:effectRef>
+          <a:fontRef idx="minor">
+            <a:schemeClr val="lt1"/>
+          </a:fontRef>
+        </p:style>
+        <p:txBody>
+          <a:bodyPr rtlCol="0" anchor="ctr" wrap="square" lIns="25400" rIns="25400" tIns="25400" bIns="25400"/>
+          <a:lstStyle/>
+          <a:p>
+            <a:pPr algn="ctr"/>
+            <a:r>
+              <a:rPr sz="900" b="0">
+                <a:solidFill>
+                  <a:srgbClr val="4F4D47"/>
+                </a:solidFill>
+                <a:latin typeface="Inter"/>
+              </a:rPr>
+              <a:t>n/a</a:t>
+            </a:r>
+          </a:p>
+        </p:txBody>
+      </p:sp>
+      <p:sp>
+        <p:nvSpPr>
+          <p:cNvPr id="22" name="Rounded Rectangle 21"/>
+          <p:cNvSpPr/>
+          <p:nvPr/>
+        </p:nvSpPr>
+        <p:spPr>
+          <a:xfrm>
+            <a:off x="4382947" y="3324758"/>
+            <a:ext cx="2394127" cy="382219"/>
+          </a:xfrm>
+          <a:prstGeom prst="roundRect">
+            <a:avLst>
+              <a:gd name="adj" fmla="val 6000"/>
+            </a:avLst>
+          </a:prstGeom>
+          <a:solidFill>
+            <a:srgbClr val="CF8692"/>
+          </a:solidFill>
+          <a:ln>
+            <a:noFill/>
+          </a:ln>
+          <a:effectLst/>
+        </p:spPr>
+        <p:style>
+          <a:lnRef idx="1">
+            <a:schemeClr val="accent1"/>
+          </a:lnRef>
+          <a:fillRef idx="3">
+            <a:schemeClr val="accent1"/>
+          </a:fillRef>
+          <a:effectRef idx="2">
+            <a:schemeClr val="accent1"/>
+          </a:effectRef>
+          <a:fontRef idx="minor">
+            <a:schemeClr val="lt1"/>
+          </a:fontRef>
+        </p:style>
+        <p:txBody>
+          <a:bodyPr rtlCol="0" anchor="ctr" wrap="square" lIns="25400" rIns="25400" tIns="25400" bIns="25400"/>
+          <a:lstStyle/>
+          <a:p>
+            <a:pPr algn="ctr"/>
+            <a:r>
+              <a:rPr sz="1500" b="1">
+                <a:solidFill>
+                  <a:srgbClr val="08080C"/>
+                </a:solidFill>
+                <a:latin typeface="JetBrains Mono"/>
+              </a:rPr>
+              <a:t>8.3</a:t>
+            </a:r>
+          </a:p>
+        </p:txBody>
+      </p:sp>
+      <p:sp>
+        <p:nvSpPr>
+          <p:cNvPr id="23" name="Rounded Rectangle 22"/>
+          <p:cNvSpPr/>
+          <p:nvPr/>
+        </p:nvSpPr>
+        <p:spPr>
+          <a:xfrm>
+            <a:off x="6809078" y="3324758"/>
+            <a:ext cx="2394127" cy="382219"/>
+          </a:xfrm>
+          <a:prstGeom prst="roundRect">
+            <a:avLst>
+              <a:gd name="adj" fmla="val 6000"/>
+            </a:avLst>
+          </a:prstGeom>
+          <a:solidFill>
+            <a:srgbClr val="DE9FA9"/>
+          </a:solidFill>
+          <a:ln>
+            <a:noFill/>
+          </a:ln>
+          <a:effectLst/>
+        </p:spPr>
+        <p:style>
+          <a:lnRef idx="1">
+            <a:schemeClr val="accent1"/>
+          </a:lnRef>
+          <a:fillRef idx="3">
+            <a:schemeClr val="accent1"/>
+          </a:fillRef>
+          <a:effectRef idx="2">
+            <a:schemeClr val="accent1"/>
+          </a:effectRef>
+          <a:fontRef idx="minor">
+            <a:schemeClr val="lt1"/>
+          </a:fontRef>
+        </p:style>
+        <p:txBody>
+          <a:bodyPr rtlCol="0" anchor="ctr" wrap="square" lIns="25400" rIns="25400" tIns="25400" bIns="25400"/>
+          <a:lstStyle/>
+          <a:p>
+            <a:pPr algn="ctr"/>
+            <a:r>
+              <a:rPr sz="1500" b="1">
+                <a:solidFill>
+                  <a:srgbClr val="08080C"/>
+                </a:solidFill>
+                <a:latin typeface="JetBrains Mono"/>
+              </a:rPr>
+              <a:t>9.0</a:t>
+            </a:r>
+          </a:p>
+        </p:txBody>
+      </p:sp>
+      <p:sp>
+        <p:nvSpPr>
+          <p:cNvPr id="24" name="Rounded Rectangle 23"/>
+          <p:cNvSpPr/>
+          <p:nvPr/>
+        </p:nvSpPr>
+        <p:spPr>
+          <a:xfrm>
+            <a:off x="9235209" y="3324758"/>
+            <a:ext cx="2394127" cy="382219"/>
+          </a:xfrm>
+          <a:prstGeom prst="roundRect">
+            <a:avLst>
+              <a:gd name="adj" fmla="val 6000"/>
+            </a:avLst>
+          </a:prstGeom>
+          <a:solidFill>
+            <a:srgbClr val="D18A95"/>
+          </a:solidFill>
+          <a:ln>
+            <a:noFill/>
+          </a:ln>
+          <a:effectLst/>
+        </p:spPr>
+        <p:style>
+          <a:lnRef idx="1">
+            <a:schemeClr val="accent1"/>
+          </a:lnRef>
+          <a:fillRef idx="3">
+            <a:schemeClr val="accent1"/>
+          </a:fillRef>
+          <a:effectRef idx="2">
+            <a:schemeClr val="accent1"/>
+          </a:effectRef>
+          <a:fontRef idx="minor">
+            <a:schemeClr val="lt1"/>
+          </a:fontRef>
+        </p:style>
+        <p:txBody>
+          <a:bodyPr rtlCol="0" anchor="ctr" wrap="square" lIns="25400" rIns="25400" tIns="25400" bIns="25400"/>
+          <a:lstStyle/>
+          <a:p>
+            <a:pPr algn="ctr"/>
+            <a:r>
+              <a:rPr sz="1500" b="1">
+                <a:solidFill>
+                  <a:srgbClr val="08080C"/>
+                </a:solidFill>
+                <a:latin typeface="JetBrains Mono"/>
+              </a:rPr>
+              <a:t>8.4</a:t>
+            </a:r>
+          </a:p>
+        </p:txBody>
+      </p:sp>
+      <p:sp>
+        <p:nvSpPr>
+          <p:cNvPr id="25" name="TextBox 24"/>
+          <p:cNvSpPr txBox="1"/>
+          <p:nvPr/>
+        </p:nvSpPr>
+        <p:spPr>
+          <a:xfrm>
+            <a:off x="658368" y="3738981"/>
+            <a:ext cx="1207008" cy="382219"/>
+          </a:xfrm>
+          <a:prstGeom prst="rect">
+            <a:avLst/>
+          </a:prstGeom>
+          <a:noFill/>
+        </p:spPr>
+        <p:txBody>
+          <a:bodyPr wrap="square" anchor="ctr" lIns="0" rIns="0" tIns="0" bIns="0">
+            <a:spAutoFit/>
+          </a:bodyPr>
+          <a:lstStyle/>
+          <a:p>
+            <a:pPr algn="r"/>
+            <a:r>
+              <a:rPr sz="1150" b="1" i="0">
+                <a:solidFill>
+                  <a:srgbClr val="C9C6BF"/>
+                </a:solidFill>
+                <a:latin typeface="Inter"/>
+              </a:rPr>
+              <a:t>Qwen 3.8-27B</a:t>
+            </a:r>
+          </a:p>
+        </p:txBody>
+      </p:sp>
+      <p:sp>
+        <p:nvSpPr>
+          <p:cNvPr id="26" name="Rounded Rectangle 25"/>
+          <p:cNvSpPr/>
+          <p:nvPr/>
+        </p:nvSpPr>
+        <p:spPr>
+          <a:xfrm>
+            <a:off x="1956816" y="3738981"/>
+            <a:ext cx="2394127" cy="382219"/>
+          </a:xfrm>
+          <a:prstGeom prst="roundRect">
+            <a:avLst>
+              <a:gd name="adj" fmla="val 6000"/>
+            </a:avLst>
+          </a:prstGeom>
+          <a:noFill/>
+          <a:ln w="9525">
+            <a:solidFill>
+              <a:srgbClr val="3A3A48"/>
+            </a:solidFill>
+            <a:prstDash val="dash"/>
+          </a:ln>
+          <a:effectLst/>
+        </p:spPr>
+        <p:style>
+          <a:lnRef idx="1">
+            <a:schemeClr val="accent1"/>
+          </a:lnRef>
+          <a:fillRef idx="3">
+            <a:schemeClr val="accent1"/>
+          </a:fillRef>
+          <a:effectRef idx="2">
+            <a:schemeClr val="accent1"/>
+          </a:effectRef>
+          <a:fontRef idx="minor">
+            <a:schemeClr val="lt1"/>
+          </a:fontRef>
+        </p:style>
+        <p:txBody>
+          <a:bodyPr rtlCol="0" anchor="ctr" wrap="square" lIns="25400" rIns="25400" tIns="25400" bIns="25400"/>
+          <a:lstStyle/>
+          <a:p>
+            <a:pPr algn="ctr"/>
+            <a:r>
+              <a:rPr sz="900" b="0">
+                <a:solidFill>
+                  <a:srgbClr val="4F4D47"/>
+                </a:solidFill>
+                <a:latin typeface="Inter"/>
+              </a:rPr>
+              <a:t>n/a</a:t>
+            </a:r>
+          </a:p>
+        </p:txBody>
+      </p:sp>
+      <p:sp>
+        <p:nvSpPr>
+          <p:cNvPr id="27" name="Rounded Rectangle 26"/>
+          <p:cNvSpPr/>
+          <p:nvPr/>
+        </p:nvSpPr>
+        <p:spPr>
+          <a:xfrm>
+            <a:off x="4382947" y="3738981"/>
+            <a:ext cx="2394127" cy="382219"/>
+          </a:xfrm>
+          <a:prstGeom prst="roundRect">
+            <a:avLst>
+              <a:gd name="adj" fmla="val 6000"/>
+            </a:avLst>
+          </a:prstGeom>
+          <a:solidFill>
+            <a:srgbClr val="C77884"/>
+          </a:solidFill>
+          <a:ln>
+            <a:noFill/>
+          </a:ln>
+          <a:effectLst/>
+        </p:spPr>
+        <p:style>
+          <a:lnRef idx="1">
+            <a:schemeClr val="accent1"/>
+          </a:lnRef>
+          <a:fillRef idx="3">
+            <a:schemeClr val="accent1"/>
+          </a:fillRef>
+          <a:effectRef idx="2">
+            <a:schemeClr val="accent1"/>
+          </a:effectRef>
+          <a:fontRef idx="minor">
+            <a:schemeClr val="lt1"/>
+          </a:fontRef>
+        </p:style>
+        <p:txBody>
+          <a:bodyPr rtlCol="0" anchor="ctr" wrap="square" lIns="25400" rIns="25400" tIns="25400" bIns="25400"/>
+          <a:lstStyle/>
+          <a:p>
+            <a:pPr algn="ctr"/>
+            <a:r>
+              <a:rPr sz="1500" b="1">
+                <a:solidFill>
+                  <a:srgbClr val="08080C"/>
+                </a:solidFill>
+                <a:latin typeface="JetBrains Mono"/>
+              </a:rPr>
+              <a:t>7.9</a:t>
+            </a:r>
+          </a:p>
+        </p:txBody>
+      </p:sp>
+      <p:sp>
+        <p:nvSpPr>
+          <p:cNvPr id="28" name="Rounded Rectangle 27"/>
+          <p:cNvSpPr/>
+          <p:nvPr/>
+        </p:nvSpPr>
+        <p:spPr>
+          <a:xfrm>
+            <a:off x="6809078" y="3738981"/>
+            <a:ext cx="2394127" cy="382219"/>
+          </a:xfrm>
+          <a:prstGeom prst="roundRect">
+            <a:avLst>
+              <a:gd name="adj" fmla="val 6000"/>
+            </a:avLst>
+          </a:prstGeom>
+          <a:solidFill>
+            <a:srgbClr val="C97C88"/>
+          </a:solidFill>
+          <a:ln>
+            <a:noFill/>
+          </a:ln>
+          <a:effectLst/>
+        </p:spPr>
+        <p:style>
+          <a:lnRef idx="1">
+            <a:schemeClr val="accent1"/>
+          </a:lnRef>
+          <a:fillRef idx="3">
+            <a:schemeClr val="accent1"/>
+          </a:fillRef>
+          <a:effectRef idx="2">
+            <a:schemeClr val="accent1"/>
+          </a:effectRef>
+          <a:fontRef idx="minor">
+            <a:schemeClr val="lt1"/>
+          </a:fontRef>
+        </p:style>
+        <p:txBody>
+          <a:bodyPr rtlCol="0" anchor="ctr" wrap="square" lIns="25400" rIns="25400" tIns="25400" bIns="25400"/>
+          <a:lstStyle/>
+          <a:p>
+            <a:pPr algn="ctr"/>
+            <a:r>
+              <a:rPr sz="1500" b="1">
+                <a:solidFill>
+                  <a:srgbClr val="08080C"/>
+                </a:solidFill>
+                <a:latin typeface="JetBrains Mono"/>
+              </a:rPr>
+              <a:t>8.0</a:t>
+            </a:r>
+          </a:p>
+        </p:txBody>
+      </p:sp>
+      <p:sp>
+        <p:nvSpPr>
+          <p:cNvPr id="29" name="Oval 28"/>
+          <p:cNvSpPr/>
+          <p:nvPr/>
+        </p:nvSpPr>
+        <p:spPr>
+          <a:xfrm>
+            <a:off x="9088905" y="3789273"/>
+            <a:ext cx="64008" cy="64008"/>
+          </a:xfrm>
+          <a:prstGeom prst="ellipse">
+            <a:avLst/>
+          </a:prstGeom>
+          <a:solidFill>
+            <a:srgbClr val="F5DC5E"/>
+          </a:solidFill>
+          <a:ln>
+            <a:noFill/>
+          </a:ln>
+          <a:effectLst/>
+        </p:spPr>
+        <p:style>
+          <a:lnRef idx="1">
+            <a:schemeClr val="accent1"/>
+          </a:lnRef>
+          <a:fillRef idx="3">
+            <a:schemeClr val="accent1"/>
+          </a:fillRef>
+          <a:effectRef idx="2">
+            <a:schemeClr val="accent1"/>
+          </a:effectRef>
+          <a:fontRef idx="minor">
+            <a:schemeClr val="lt1"/>
+          </a:fontRef>
+        </p:style>
+        <p:txBody>
+          <a:bodyPr rtlCol="0" anchor="ctr"/>
+          <a:lstStyle/>
+          <a:p>
+            <a:pPr algn="ctr"/>
+          </a:p>
+        </p:txBody>
+      </p:sp>
+      <p:sp>
+        <p:nvSpPr>
+          <p:cNvPr id="30" name="Rounded Rectangle 29"/>
+          <p:cNvSpPr/>
+          <p:nvPr/>
+        </p:nvSpPr>
+        <p:spPr>
+          <a:xfrm>
+            <a:off x="9235209" y="3738981"/>
+            <a:ext cx="2394127" cy="382219"/>
+          </a:xfrm>
+          <a:prstGeom prst="roundRect">
+            <a:avLst>
+              <a:gd name="adj" fmla="val 6000"/>
+            </a:avLst>
+          </a:prstGeom>
+          <a:solidFill>
+            <a:srgbClr val="5A111C"/>
+          </a:solidFill>
+          <a:ln w="15875">
+            <a:solidFill>
+              <a:srgbClr val="F56B8C"/>
+            </a:solidFill>
+            <a:prstDash val="dash"/>
+          </a:ln>
+          <a:effectLst/>
+        </p:spPr>
+        <p:style>
+          <a:lnRef idx="1">
+            <a:schemeClr val="accent1"/>
+          </a:lnRef>
+          <a:fillRef idx="3">
+            <a:schemeClr val="accent1"/>
+          </a:fillRef>
+          <a:effectRef idx="2">
+            <a:schemeClr val="accent1"/>
+          </a:effectRef>
+          <a:fontRef idx="minor">
+            <a:schemeClr val="lt1"/>
+          </a:fontRef>
+        </p:style>
+        <p:txBody>
+          <a:bodyPr rtlCol="0" anchor="ctr" wrap="square" lIns="25400" rIns="25400" tIns="25400" bIns="25400"/>
+          <a:lstStyle/>
+          <a:p>
+            <a:pPr algn="ctr"/>
+            <a:r>
+              <a:rPr sz="1500" b="1">
+                <a:solidFill>
+                  <a:srgbClr val="E8E6E1"/>
+                </a:solidFill>
+                <a:latin typeface="JetBrains Mono"/>
+              </a:rPr>
+              <a:t>2.5</a:t>
+            </a:r>
+          </a:p>
+        </p:txBody>
+      </p:sp>
+      <p:sp>
+        <p:nvSpPr>
+          <p:cNvPr id="31" name="TextBox 30"/>
+          <p:cNvSpPr txBox="1"/>
+          <p:nvPr/>
+        </p:nvSpPr>
+        <p:spPr>
+          <a:xfrm>
+            <a:off x="658368" y="4153204"/>
+            <a:ext cx="1207008" cy="382219"/>
+          </a:xfrm>
+          <a:prstGeom prst="rect">
+            <a:avLst/>
+          </a:prstGeom>
+          <a:noFill/>
+        </p:spPr>
+        <p:txBody>
+          <a:bodyPr wrap="square" anchor="ctr" lIns="0" rIns="0" tIns="0" bIns="0">
+            <a:spAutoFit/>
+          </a:bodyPr>
+          <a:lstStyle/>
+          <a:p>
+            <a:pPr algn="r"/>
+            <a:r>
+              <a:rPr sz="1150" b="1" i="0">
+                <a:solidFill>
+                  <a:srgbClr val="C9C6BF"/>
+                </a:solidFill>
+                <a:latin typeface="Inter"/>
+              </a:rPr>
+              <a:t>Qwen 3.8 Max</a:t>
+            </a:r>
+          </a:p>
+        </p:txBody>
+      </p:sp>
+      <p:sp>
+        <p:nvSpPr>
+          <p:cNvPr id="32" name="Rounded Rectangle 31"/>
+          <p:cNvSpPr/>
+          <p:nvPr/>
+        </p:nvSpPr>
+        <p:spPr>
+          <a:xfrm>
+            <a:off x="1956816" y="4153204"/>
+            <a:ext cx="2394127" cy="382219"/>
+          </a:xfrm>
+          <a:prstGeom prst="roundRect">
+            <a:avLst>
+              <a:gd name="adj" fmla="val 6000"/>
+            </a:avLst>
+          </a:prstGeom>
+          <a:noFill/>
+          <a:ln w="9525">
+            <a:solidFill>
+              <a:srgbClr val="3A3A48"/>
+            </a:solidFill>
+            <a:prstDash val="dash"/>
+          </a:ln>
+          <a:effectLst/>
+        </p:spPr>
+        <p:style>
+          <a:lnRef idx="1">
+            <a:schemeClr val="accent1"/>
+          </a:lnRef>
+          <a:fillRef idx="3">
+            <a:schemeClr val="accent1"/>
+          </a:fillRef>
+          <a:effectRef idx="2">
+            <a:schemeClr val="accent1"/>
+          </a:effectRef>
+          <a:fontRef idx="minor">
+            <a:schemeClr val="lt1"/>
+          </a:fontRef>
+        </p:style>
+        <p:txBody>
+          <a:bodyPr rtlCol="0" anchor="ctr" wrap="square" lIns="25400" rIns="25400" tIns="25400" bIns="25400"/>
+          <a:lstStyle/>
+          <a:p>
+            <a:pPr algn="ctr"/>
+            <a:r>
+              <a:rPr sz="900" b="0">
+                <a:solidFill>
+                  <a:srgbClr val="4F4D47"/>
+                </a:solidFill>
+                <a:latin typeface="Inter"/>
+              </a:rPr>
+              <a:t>n/a</a:t>
+            </a:r>
+          </a:p>
+        </p:txBody>
+      </p:sp>
+      <p:sp>
+        <p:nvSpPr>
+          <p:cNvPr id="33" name="Rounded Rectangle 32"/>
+          <p:cNvSpPr/>
+          <p:nvPr/>
+        </p:nvSpPr>
+        <p:spPr>
+          <a:xfrm>
+            <a:off x="4382947" y="4153204"/>
+            <a:ext cx="2394127" cy="382219"/>
+          </a:xfrm>
+          <a:prstGeom prst="roundRect">
+            <a:avLst>
+              <a:gd name="adj" fmla="val 6000"/>
+            </a:avLst>
+          </a:prstGeom>
+          <a:solidFill>
+            <a:srgbClr val="C57581"/>
+          </a:solidFill>
+          <a:ln>
+            <a:noFill/>
+          </a:ln>
+          <a:effectLst/>
+        </p:spPr>
+        <p:style>
+          <a:lnRef idx="1">
+            <a:schemeClr val="accent1"/>
+          </a:lnRef>
+          <a:fillRef idx="3">
+            <a:schemeClr val="accent1"/>
+          </a:fillRef>
+          <a:effectRef idx="2">
+            <a:schemeClr val="accent1"/>
+          </a:effectRef>
+          <a:fontRef idx="minor">
+            <a:schemeClr val="lt1"/>
+          </a:fontRef>
+        </p:style>
+        <p:txBody>
+          <a:bodyPr rtlCol="0" anchor="ctr" wrap="square" lIns="25400" rIns="25400" tIns="25400" bIns="25400"/>
+          <a:lstStyle/>
+          <a:p>
+            <a:pPr algn="ctr"/>
+            <a:r>
+              <a:rPr sz="1500" b="1">
+                <a:solidFill>
+                  <a:srgbClr val="08080C"/>
+                </a:solidFill>
+                <a:latin typeface="JetBrains Mono"/>
+              </a:rPr>
+              <a:t>7.8</a:t>
+            </a:r>
+          </a:p>
+        </p:txBody>
+      </p:sp>
+      <p:sp>
+        <p:nvSpPr>
+          <p:cNvPr id="34" name="Oval 33"/>
+          <p:cNvSpPr/>
+          <p:nvPr/>
+        </p:nvSpPr>
+        <p:spPr>
+          <a:xfrm>
+            <a:off x="6662774" y="4203496"/>
+            <a:ext cx="64008" cy="64008"/>
+          </a:xfrm>
+          <a:prstGeom prst="ellipse">
+            <a:avLst/>
+          </a:prstGeom>
+          <a:solidFill>
+            <a:srgbClr val="F5DC5E"/>
+          </a:solidFill>
+          <a:ln>
+            <a:noFill/>
+          </a:ln>
+          <a:effectLst/>
+        </p:spPr>
+        <p:style>
+          <a:lnRef idx="1">
+            <a:schemeClr val="accent1"/>
+          </a:lnRef>
+          <a:fillRef idx="3">
+            <a:schemeClr val="accent1"/>
+          </a:fillRef>
+          <a:effectRef idx="2">
+            <a:schemeClr val="accent1"/>
+          </a:effectRef>
+          <a:fontRef idx="minor">
+            <a:schemeClr val="lt1"/>
+          </a:fontRef>
+        </p:style>
+        <p:txBody>
+          <a:bodyPr rtlCol="0" anchor="ctr"/>
+          <a:lstStyle/>
+          <a:p>
+            <a:pPr algn="ctr"/>
+          </a:p>
+        </p:txBody>
+      </p:sp>
+      <p:sp>
+        <p:nvSpPr>
+          <p:cNvPr id="35" name="Rounded Rectangle 34"/>
+          <p:cNvSpPr/>
+          <p:nvPr/>
+        </p:nvSpPr>
+        <p:spPr>
+          <a:xfrm>
+            <a:off x="6809078" y="4153204"/>
+            <a:ext cx="2394127" cy="382219"/>
+          </a:xfrm>
+          <a:prstGeom prst="roundRect">
+            <a:avLst>
+              <a:gd name="adj" fmla="val 6000"/>
+            </a:avLst>
+          </a:prstGeom>
+          <a:solidFill>
+            <a:srgbClr val="DE9FA9"/>
+          </a:solidFill>
+          <a:ln>
+            <a:noFill/>
+          </a:ln>
+          <a:effectLst/>
+        </p:spPr>
+        <p:style>
+          <a:lnRef idx="1">
+            <a:schemeClr val="accent1"/>
+          </a:lnRef>
+          <a:fillRef idx="3">
+            <a:schemeClr val="accent1"/>
+          </a:fillRef>
+          <a:effectRef idx="2">
+            <a:schemeClr val="accent1"/>
+          </a:effectRef>
+          <a:fontRef idx="minor">
+            <a:schemeClr val="lt1"/>
+          </a:fontRef>
+        </p:style>
+        <p:txBody>
+          <a:bodyPr rtlCol="0" anchor="ctr" wrap="square" lIns="25400" rIns="25400" tIns="25400" bIns="25400"/>
+          <a:lstStyle/>
+          <a:p>
+            <a:pPr algn="ctr"/>
+            <a:r>
+              <a:rPr sz="1500" b="1">
+                <a:solidFill>
+                  <a:srgbClr val="08080C"/>
+                </a:solidFill>
+                <a:latin typeface="JetBrains Mono"/>
+              </a:rPr>
+              <a:t>9.0</a:t>
+            </a:r>
+          </a:p>
+        </p:txBody>
+      </p:sp>
+      <p:sp>
+        <p:nvSpPr>
+          <p:cNvPr id="36" name="Rounded Rectangle 35"/>
+          <p:cNvSpPr/>
+          <p:nvPr/>
+        </p:nvSpPr>
+        <p:spPr>
+          <a:xfrm>
+            <a:off x="9235209" y="4153204"/>
+            <a:ext cx="2394127" cy="382219"/>
+          </a:xfrm>
+          <a:prstGeom prst="roundRect">
+            <a:avLst>
+              <a:gd name="adj" fmla="val 6000"/>
+            </a:avLst>
+          </a:prstGeom>
+          <a:solidFill>
+            <a:srgbClr val="9F3545"/>
+          </a:solidFill>
+          <a:ln>
+            <a:noFill/>
+          </a:ln>
+          <a:effectLst/>
+        </p:spPr>
+        <p:style>
+          <a:lnRef idx="1">
+            <a:schemeClr val="accent1"/>
+          </a:lnRef>
+          <a:fillRef idx="3">
+            <a:schemeClr val="accent1"/>
+          </a:fillRef>
+          <a:effectRef idx="2">
+            <a:schemeClr val="accent1"/>
+          </a:effectRef>
+          <a:fontRef idx="minor">
+            <a:schemeClr val="lt1"/>
+          </a:fontRef>
+        </p:style>
+        <p:txBody>
+          <a:bodyPr rtlCol="0" anchor="ctr" wrap="square" lIns="25400" rIns="25400" tIns="25400" bIns="25400"/>
+          <a:lstStyle/>
+          <a:p>
+            <a:pPr algn="ctr"/>
+            <a:r>
+              <a:rPr sz="1500" b="1">
+                <a:solidFill>
+                  <a:srgbClr val="E8E6E1"/>
+                </a:solidFill>
+                <a:latin typeface="JetBrains Mono"/>
+              </a:rPr>
+              <a:t>6.0</a:t>
+            </a:r>
+          </a:p>
+        </p:txBody>
+      </p:sp>
+      <p:sp>
+        <p:nvSpPr>
+          <p:cNvPr id="37" name="TextBox 36"/>
+          <p:cNvSpPr txBox="1"/>
+          <p:nvPr/>
+        </p:nvSpPr>
+        <p:spPr>
+          <a:xfrm>
+            <a:off x="658368" y="4567427"/>
+            <a:ext cx="1207008" cy="382219"/>
+          </a:xfrm>
+          <a:prstGeom prst="rect">
+            <a:avLst/>
+          </a:prstGeom>
+          <a:noFill/>
+        </p:spPr>
+        <p:txBody>
+          <a:bodyPr wrap="square" anchor="ctr" lIns="0" rIns="0" tIns="0" bIns="0">
+            <a:spAutoFit/>
+          </a:bodyPr>
+          <a:lstStyle/>
+          <a:p>
+            <a:pPr algn="r"/>
+            <a:r>
+              <a:rPr sz="1150" b="1" i="0">
+                <a:solidFill>
+                  <a:srgbClr val="C9C6BF"/>
+                </a:solidFill>
+                <a:latin typeface="Inter"/>
+              </a:rPr>
+              <a:t>Kimi K3</a:t>
+            </a:r>
+          </a:p>
+        </p:txBody>
+      </p:sp>
+      <p:sp>
+        <p:nvSpPr>
+          <p:cNvPr id="38" name="Rounded Rectangle 37"/>
+          <p:cNvSpPr/>
+          <p:nvPr/>
+        </p:nvSpPr>
+        <p:spPr>
+          <a:xfrm>
+            <a:off x="1956816" y="4567427"/>
+            <a:ext cx="2394127" cy="382219"/>
+          </a:xfrm>
+          <a:prstGeom prst="roundRect">
+            <a:avLst>
+              <a:gd name="adj" fmla="val 6000"/>
+            </a:avLst>
+          </a:prstGeom>
+          <a:noFill/>
+          <a:ln w="9525">
+            <a:solidFill>
+              <a:srgbClr val="3A3A48"/>
+            </a:solidFill>
+            <a:prstDash val="dash"/>
+          </a:ln>
+          <a:effectLst/>
+        </p:spPr>
+        <p:style>
+          <a:lnRef idx="1">
+            <a:schemeClr val="accent1"/>
+          </a:lnRef>
+          <a:fillRef idx="3">
+            <a:schemeClr val="accent1"/>
+          </a:fillRef>
+          <a:effectRef idx="2">
+            <a:schemeClr val="accent1"/>
+          </a:effectRef>
+          <a:fontRef idx="minor">
+            <a:schemeClr val="lt1"/>
+          </a:fontRef>
+        </p:style>
+        <p:txBody>
+          <a:bodyPr rtlCol="0" anchor="ctr" wrap="square" lIns="25400" rIns="25400" tIns="25400" bIns="25400"/>
+          <a:lstStyle/>
+          <a:p>
+            <a:pPr algn="ctr"/>
+            <a:r>
+              <a:rPr sz="900" b="0">
+                <a:solidFill>
+                  <a:srgbClr val="4F4D47"/>
+                </a:solidFill>
+                <a:latin typeface="Inter"/>
+              </a:rPr>
+              <a:t>n/a</a:t>
+            </a:r>
+          </a:p>
+        </p:txBody>
+      </p:sp>
+      <p:sp>
+        <p:nvSpPr>
+          <p:cNvPr id="39" name="Rounded Rectangle 38"/>
+          <p:cNvSpPr/>
+          <p:nvPr/>
+        </p:nvSpPr>
+        <p:spPr>
+          <a:xfrm>
+            <a:off x="4382947" y="4567427"/>
+            <a:ext cx="2394127" cy="382219"/>
+          </a:xfrm>
+          <a:prstGeom prst="roundRect">
+            <a:avLst>
+              <a:gd name="adj" fmla="val 6000"/>
+            </a:avLst>
+          </a:prstGeom>
+          <a:solidFill>
+            <a:srgbClr val="B05160"/>
+          </a:solidFill>
+          <a:ln>
+            <a:noFill/>
+          </a:ln>
+          <a:effectLst/>
+        </p:spPr>
+        <p:style>
+          <a:lnRef idx="1">
+            <a:schemeClr val="accent1"/>
+          </a:lnRef>
+          <a:fillRef idx="3">
+            <a:schemeClr val="accent1"/>
+          </a:fillRef>
+          <a:effectRef idx="2">
+            <a:schemeClr val="accent1"/>
+          </a:effectRef>
+          <a:fontRef idx="minor">
+            <a:schemeClr val="lt1"/>
+          </a:fontRef>
+        </p:style>
+        <p:txBody>
+          <a:bodyPr rtlCol="0" anchor="ctr" wrap="square" lIns="25400" rIns="25400" tIns="25400" bIns="25400"/>
+          <a:lstStyle/>
+          <a:p>
+            <a:pPr algn="ctr"/>
+            <a:r>
+              <a:rPr sz="1500" b="1">
+                <a:solidFill>
+                  <a:srgbClr val="E8E6E1"/>
+                </a:solidFill>
+                <a:latin typeface="JetBrains Mono"/>
+              </a:rPr>
+              <a:t>6.8</a:t>
+            </a:r>
+          </a:p>
+        </p:txBody>
+      </p:sp>
+      <p:sp>
+        <p:nvSpPr>
+          <p:cNvPr id="40" name="Oval 39"/>
+          <p:cNvSpPr/>
+          <p:nvPr/>
+        </p:nvSpPr>
+        <p:spPr>
+          <a:xfrm>
+            <a:off x="6662774" y="4617719"/>
+            <a:ext cx="64008" cy="64008"/>
+          </a:xfrm>
+          <a:prstGeom prst="ellipse">
+            <a:avLst/>
+          </a:prstGeom>
+          <a:solidFill>
+            <a:srgbClr val="F5DC5E"/>
+          </a:solidFill>
+          <a:ln>
+            <a:noFill/>
+          </a:ln>
+          <a:effectLst/>
+        </p:spPr>
+        <p:style>
+          <a:lnRef idx="1">
+            <a:schemeClr val="accent1"/>
+          </a:lnRef>
+          <a:fillRef idx="3">
+            <a:schemeClr val="accent1"/>
+          </a:fillRef>
+          <a:effectRef idx="2">
+            <a:schemeClr val="accent1"/>
+          </a:effectRef>
+          <a:fontRef idx="minor">
+            <a:schemeClr val="lt1"/>
+          </a:fontRef>
+        </p:style>
+        <p:txBody>
+          <a:bodyPr rtlCol="0" anchor="ctr"/>
+          <a:lstStyle/>
+          <a:p>
+            <a:pPr algn="ctr"/>
+          </a:p>
+        </p:txBody>
+      </p:sp>
+      <p:sp>
+        <p:nvSpPr>
+          <p:cNvPr id="41" name="Rounded Rectangle 40"/>
+          <p:cNvSpPr/>
+          <p:nvPr/>
+        </p:nvSpPr>
+        <p:spPr>
+          <a:xfrm>
+            <a:off x="6809078" y="4567427"/>
+            <a:ext cx="2394127" cy="382219"/>
+          </a:xfrm>
+          <a:prstGeom prst="roundRect">
+            <a:avLst>
+              <a:gd name="adj" fmla="val 6000"/>
+            </a:avLst>
+          </a:prstGeom>
+          <a:solidFill>
+            <a:srgbClr val="E4A9B3"/>
+          </a:solidFill>
+          <a:ln>
+            <a:noFill/>
+          </a:ln>
+          <a:effectLst/>
+        </p:spPr>
+        <p:style>
+          <a:lnRef idx="1">
+            <a:schemeClr val="accent1"/>
+          </a:lnRef>
+          <a:fillRef idx="3">
+            <a:schemeClr val="accent1"/>
+          </a:fillRef>
+          <a:effectRef idx="2">
+            <a:schemeClr val="accent1"/>
+          </a:effectRef>
+          <a:fontRef idx="minor">
+            <a:schemeClr val="lt1"/>
+          </a:fontRef>
+        </p:style>
+        <p:txBody>
+          <a:bodyPr rtlCol="0" anchor="ctr" wrap="square" lIns="25400" rIns="25400" tIns="25400" bIns="25400"/>
+          <a:lstStyle/>
+          <a:p>
+            <a:pPr algn="ctr"/>
+            <a:r>
+              <a:rPr sz="1500" b="1">
+                <a:solidFill>
+                  <a:srgbClr val="08080C"/>
+                </a:solidFill>
+                <a:latin typeface="JetBrains Mono"/>
+              </a:rPr>
+              <a:t>9.3</a:t>
+            </a:r>
+          </a:p>
+        </p:txBody>
+      </p:sp>
+      <p:sp>
+        <p:nvSpPr>
+          <p:cNvPr id="42" name="Rounded Rectangle 41"/>
+          <p:cNvSpPr/>
+          <p:nvPr/>
+        </p:nvSpPr>
+        <p:spPr>
+          <a:xfrm>
+            <a:off x="9235209" y="4567427"/>
+            <a:ext cx="2394127" cy="382219"/>
+          </a:xfrm>
+          <a:prstGeom prst="roundRect">
+            <a:avLst>
+              <a:gd name="adj" fmla="val 6000"/>
+            </a:avLst>
+          </a:prstGeom>
+          <a:solidFill>
+            <a:srgbClr val="C77884"/>
+          </a:solidFill>
+          <a:ln>
+            <a:noFill/>
+          </a:ln>
+          <a:effectLst/>
+        </p:spPr>
+        <p:style>
+          <a:lnRef idx="1">
+            <a:schemeClr val="accent1"/>
+          </a:lnRef>
+          <a:fillRef idx="3">
+            <a:schemeClr val="accent1"/>
+          </a:fillRef>
+          <a:effectRef idx="2">
+            <a:schemeClr val="accent1"/>
+          </a:effectRef>
+          <a:fontRef idx="minor">
+            <a:schemeClr val="lt1"/>
+          </a:fontRef>
+        </p:style>
+        <p:txBody>
+          <a:bodyPr rtlCol="0" anchor="ctr" wrap="square" lIns="25400" rIns="25400" tIns="25400" bIns="25400"/>
+          <a:lstStyle/>
+          <a:p>
+            <a:pPr algn="ctr"/>
+            <a:r>
+              <a:rPr sz="1500" b="1">
+                <a:solidFill>
+                  <a:srgbClr val="08080C"/>
+                </a:solidFill>
+                <a:latin typeface="JetBrains Mono"/>
+              </a:rPr>
+              <a:t>7.9</a:t>
+            </a:r>
+          </a:p>
+        </p:txBody>
+      </p:sp>
+      <p:sp>
+        <p:nvSpPr>
+          <p:cNvPr id="43" name="TextBox 42"/>
+          <p:cNvSpPr txBox="1"/>
+          <p:nvPr/>
+        </p:nvSpPr>
+        <p:spPr>
+          <a:xfrm>
+            <a:off x="658368" y="4981650"/>
+            <a:ext cx="1207008" cy="382219"/>
+          </a:xfrm>
+          <a:prstGeom prst="rect">
+            <a:avLst/>
+          </a:prstGeom>
+          <a:noFill/>
+        </p:spPr>
+        <p:txBody>
+          <a:bodyPr wrap="square" anchor="ctr" lIns="0" rIns="0" tIns="0" bIns="0">
+            <a:spAutoFit/>
+          </a:bodyPr>
+          <a:lstStyle/>
+          <a:p>
+            <a:pPr algn="r"/>
+            <a:r>
+              <a:rPr sz="1150" b="1" i="0">
+                <a:solidFill>
+                  <a:srgbClr val="C9C6BF"/>
+                </a:solidFill>
+                <a:latin typeface="Inter"/>
+              </a:rPr>
+              <a:t>GLM-5.3</a:t>
+            </a:r>
+          </a:p>
+        </p:txBody>
+      </p:sp>
+      <p:sp>
+        <p:nvSpPr>
+          <p:cNvPr id="44" name="Rounded Rectangle 43"/>
+          <p:cNvSpPr/>
+          <p:nvPr/>
+        </p:nvSpPr>
+        <p:spPr>
+          <a:xfrm>
+            <a:off x="1956816" y="4981650"/>
+            <a:ext cx="2394127" cy="382219"/>
+          </a:xfrm>
+          <a:prstGeom prst="roundRect">
+            <a:avLst>
+              <a:gd name="adj" fmla="val 6000"/>
+            </a:avLst>
+          </a:prstGeom>
+          <a:noFill/>
+          <a:ln w="9525">
+            <a:solidFill>
+              <a:srgbClr val="3A3A48"/>
+            </a:solidFill>
+            <a:prstDash val="dash"/>
+          </a:ln>
+          <a:effectLst/>
+        </p:spPr>
+        <p:style>
+          <a:lnRef idx="1">
+            <a:schemeClr val="accent1"/>
+          </a:lnRef>
+          <a:fillRef idx="3">
+            <a:schemeClr val="accent1"/>
+          </a:fillRef>
+          <a:effectRef idx="2">
+            <a:schemeClr val="accent1"/>
+          </a:effectRef>
+          <a:fontRef idx="minor">
+            <a:schemeClr val="lt1"/>
+          </a:fontRef>
+        </p:style>
+        <p:txBody>
+          <a:bodyPr rtlCol="0" anchor="ctr" wrap="square" lIns="25400" rIns="25400" tIns="25400" bIns="25400"/>
+          <a:lstStyle/>
+          <a:p>
+            <a:pPr algn="ctr"/>
+            <a:r>
+              <a:rPr sz="900" b="0">
+                <a:solidFill>
+                  <a:srgbClr val="4F4D47"/>
+                </a:solidFill>
+                <a:latin typeface="Inter"/>
+              </a:rPr>
+              <a:t>n/a</a:t>
+            </a:r>
+          </a:p>
+        </p:txBody>
+      </p:sp>
+      <p:sp>
+        <p:nvSpPr>
+          <p:cNvPr id="45" name="Rounded Rectangle 44"/>
+          <p:cNvSpPr/>
+          <p:nvPr/>
+        </p:nvSpPr>
+        <p:spPr>
+          <a:xfrm>
+            <a:off x="4382947" y="4981650"/>
+            <a:ext cx="2394127" cy="382219"/>
+          </a:xfrm>
+          <a:prstGeom prst="roundRect">
+            <a:avLst>
+              <a:gd name="adj" fmla="val 6000"/>
+            </a:avLst>
+          </a:prstGeom>
+          <a:solidFill>
+            <a:srgbClr val="DA98A2"/>
+          </a:solidFill>
+          <a:ln>
+            <a:noFill/>
+          </a:ln>
+          <a:effectLst/>
+        </p:spPr>
+        <p:style>
+          <a:lnRef idx="1">
+            <a:schemeClr val="accent1"/>
+          </a:lnRef>
+          <a:fillRef idx="3">
+            <a:schemeClr val="accent1"/>
+          </a:fillRef>
+          <a:effectRef idx="2">
+            <a:schemeClr val="accent1"/>
+          </a:effectRef>
+          <a:fontRef idx="minor">
+            <a:schemeClr val="lt1"/>
+          </a:fontRef>
+        </p:style>
+        <p:txBody>
+          <a:bodyPr rtlCol="0" anchor="ctr" wrap="square" lIns="25400" rIns="25400" tIns="25400" bIns="25400"/>
+          <a:lstStyle/>
+          <a:p>
+            <a:pPr algn="ctr"/>
+            <a:r>
+              <a:rPr sz="1500" b="1">
+                <a:solidFill>
+                  <a:srgbClr val="08080C"/>
+                </a:solidFill>
+                <a:latin typeface="JetBrains Mono"/>
+              </a:rPr>
+              <a:t>8.8</a:t>
+            </a:r>
+          </a:p>
+        </p:txBody>
+      </p:sp>
+      <p:sp>
+        <p:nvSpPr>
+          <p:cNvPr id="46" name="Rounded Rectangle 45"/>
+          <p:cNvSpPr/>
+          <p:nvPr/>
+        </p:nvSpPr>
+        <p:spPr>
+          <a:xfrm>
+            <a:off x="6809078" y="4981650"/>
+            <a:ext cx="2394127" cy="382219"/>
+          </a:xfrm>
+          <a:prstGeom prst="roundRect">
+            <a:avLst>
+              <a:gd name="adj" fmla="val 6000"/>
+            </a:avLst>
+          </a:prstGeom>
+          <a:solidFill>
+            <a:srgbClr val="9F3545"/>
+          </a:solidFill>
+          <a:ln>
+            <a:noFill/>
+          </a:ln>
+          <a:effectLst/>
+        </p:spPr>
+        <p:style>
+          <a:lnRef idx="1">
+            <a:schemeClr val="accent1"/>
+          </a:lnRef>
+          <a:fillRef idx="3">
+            <a:schemeClr val="accent1"/>
+          </a:fillRef>
+          <a:effectRef idx="2">
+            <a:schemeClr val="accent1"/>
+          </a:effectRef>
+          <a:fontRef idx="minor">
+            <a:schemeClr val="lt1"/>
+          </a:fontRef>
+        </p:style>
+        <p:txBody>
+          <a:bodyPr rtlCol="0" anchor="ctr" wrap="square" lIns="25400" rIns="25400" tIns="25400" bIns="25400"/>
+          <a:lstStyle/>
+          <a:p>
+            <a:pPr algn="ctr"/>
+            <a:r>
+              <a:rPr sz="1500" b="1">
+                <a:solidFill>
+                  <a:srgbClr val="E8E6E1"/>
+                </a:solidFill>
+                <a:latin typeface="JetBrains Mono"/>
+              </a:rPr>
+              <a:t>6.0</a:t>
+            </a:r>
+          </a:p>
+        </p:txBody>
+      </p:sp>
+      <p:sp>
+        <p:nvSpPr>
+          <p:cNvPr id="47" name="Rounded Rectangle 46"/>
+          <p:cNvSpPr/>
+          <p:nvPr/>
+        </p:nvSpPr>
+        <p:spPr>
+          <a:xfrm>
+            <a:off x="9235209" y="4981650"/>
+            <a:ext cx="2394127" cy="382219"/>
+          </a:xfrm>
+          <a:prstGeom prst="roundRect">
+            <a:avLst>
+              <a:gd name="adj" fmla="val 6000"/>
+            </a:avLst>
+          </a:prstGeom>
+          <a:solidFill>
+            <a:srgbClr val="BE6A77"/>
+          </a:solidFill>
+          <a:ln>
+            <a:noFill/>
+          </a:ln>
+          <a:effectLst/>
+        </p:spPr>
+        <p:style>
+          <a:lnRef idx="1">
+            <a:schemeClr val="accent1"/>
+          </a:lnRef>
+          <a:fillRef idx="3">
+            <a:schemeClr val="accent1"/>
+          </a:fillRef>
+          <a:effectRef idx="2">
+            <a:schemeClr val="accent1"/>
+          </a:effectRef>
+          <a:fontRef idx="minor">
+            <a:schemeClr val="lt1"/>
+          </a:fontRef>
+        </p:style>
+        <p:txBody>
+          <a:bodyPr rtlCol="0" anchor="ctr" wrap="square" lIns="25400" rIns="25400" tIns="25400" bIns="25400"/>
+          <a:lstStyle/>
+          <a:p>
+            <a:pPr algn="ctr"/>
+            <a:r>
+              <a:rPr sz="1500" b="1">
+                <a:solidFill>
+                  <a:srgbClr val="08080C"/>
+                </a:solidFill>
+                <a:latin typeface="JetBrains Mono"/>
+              </a:rPr>
+              <a:t>7.5</a:t>
+            </a:r>
+          </a:p>
+        </p:txBody>
+      </p:sp>
+      <p:sp>
+        <p:nvSpPr>
+          <p:cNvPr id="48" name="TextBox 47"/>
+          <p:cNvSpPr txBox="1"/>
+          <p:nvPr/>
+        </p:nvSpPr>
+        <p:spPr>
+          <a:xfrm>
+            <a:off x="658368" y="5395873"/>
+            <a:ext cx="1207008" cy="382219"/>
+          </a:xfrm>
+          <a:prstGeom prst="rect">
+            <a:avLst/>
+          </a:prstGeom>
+          <a:noFill/>
+        </p:spPr>
+        <p:txBody>
+          <a:bodyPr wrap="square" anchor="ctr" lIns="0" rIns="0" tIns="0" bIns="0">
+            <a:spAutoFit/>
+          </a:bodyPr>
+          <a:lstStyle/>
+          <a:p>
+            <a:pPr algn="r"/>
+            <a:r>
+              <a:rPr sz="1150" b="1" i="0">
+                <a:solidFill>
+                  <a:srgbClr val="C9C6BF"/>
+                </a:solidFill>
+                <a:latin typeface="Inter"/>
+              </a:rPr>
+              <a:t>GLM-5.3-flash</a:t>
+            </a:r>
+          </a:p>
+        </p:txBody>
+      </p:sp>
+      <p:sp>
+        <p:nvSpPr>
+          <p:cNvPr id="49" name="Rounded Rectangle 48"/>
+          <p:cNvSpPr/>
+          <p:nvPr/>
+        </p:nvSpPr>
+        <p:spPr>
+          <a:xfrm>
+            <a:off x="1956816" y="5395873"/>
+            <a:ext cx="2394127" cy="382219"/>
+          </a:xfrm>
+          <a:prstGeom prst="roundRect">
+            <a:avLst>
+              <a:gd name="adj" fmla="val 6000"/>
+            </a:avLst>
+          </a:prstGeom>
+          <a:noFill/>
+          <a:ln w="9525">
+            <a:solidFill>
+              <a:srgbClr val="3A3A48"/>
+            </a:solidFill>
+            <a:prstDash val="dash"/>
+          </a:ln>
+          <a:effectLst/>
+        </p:spPr>
+        <p:style>
+          <a:lnRef idx="1">
+            <a:schemeClr val="accent1"/>
+          </a:lnRef>
+          <a:fillRef idx="3">
+            <a:schemeClr val="accent1"/>
+          </a:fillRef>
+          <a:effectRef idx="2">
+            <a:schemeClr val="accent1"/>
+          </a:effectRef>
+          <a:fontRef idx="minor">
+            <a:schemeClr val="lt1"/>
+          </a:fontRef>
+        </p:style>
+        <p:txBody>
+          <a:bodyPr rtlCol="0" anchor="ctr" wrap="square" lIns="25400" rIns="25400" tIns="25400" bIns="25400"/>
+          <a:lstStyle/>
+          <a:p>
+            <a:pPr algn="ctr"/>
+            <a:r>
+              <a:rPr sz="900" b="0">
+                <a:solidFill>
+                  <a:srgbClr val="4F4D47"/>
+                </a:solidFill>
+                <a:latin typeface="Inter"/>
+              </a:rPr>
+              <a:t>n/a</a:t>
+            </a:r>
+          </a:p>
+        </p:txBody>
+      </p:sp>
+      <p:sp>
+        <p:nvSpPr>
+          <p:cNvPr id="50" name="Rounded Rectangle 49"/>
+          <p:cNvSpPr/>
+          <p:nvPr/>
+        </p:nvSpPr>
+        <p:spPr>
+          <a:xfrm>
+            <a:off x="4382947" y="5395873"/>
+            <a:ext cx="2394127" cy="382219"/>
+          </a:xfrm>
+          <a:prstGeom prst="roundRect">
+            <a:avLst>
+              <a:gd name="adj" fmla="val 6000"/>
+            </a:avLst>
+          </a:prstGeom>
+          <a:solidFill>
+            <a:srgbClr val="D48D98"/>
+          </a:solidFill>
+          <a:ln>
+            <a:noFill/>
+          </a:ln>
+          <a:effectLst/>
+        </p:spPr>
+        <p:style>
+          <a:lnRef idx="1">
+            <a:schemeClr val="accent1"/>
+          </a:lnRef>
+          <a:fillRef idx="3">
+            <a:schemeClr val="accent1"/>
+          </a:fillRef>
+          <a:effectRef idx="2">
+            <a:schemeClr val="accent1"/>
+          </a:effectRef>
+          <a:fontRef idx="minor">
+            <a:schemeClr val="lt1"/>
+          </a:fontRef>
+        </p:style>
+        <p:txBody>
+          <a:bodyPr rtlCol="0" anchor="ctr" wrap="square" lIns="25400" rIns="25400" tIns="25400" bIns="25400"/>
+          <a:lstStyle/>
+          <a:p>
+            <a:pPr algn="ctr"/>
+            <a:r>
+              <a:rPr sz="1500" b="1">
+                <a:solidFill>
+                  <a:srgbClr val="08080C"/>
+                </a:solidFill>
+                <a:latin typeface="JetBrains Mono"/>
+              </a:rPr>
+              <a:t>8.5</a:t>
+            </a:r>
+          </a:p>
+        </p:txBody>
+      </p:sp>
+      <p:sp>
+        <p:nvSpPr>
+          <p:cNvPr id="51" name="Rounded Rectangle 50"/>
+          <p:cNvSpPr/>
+          <p:nvPr/>
+        </p:nvSpPr>
+        <p:spPr>
+          <a:xfrm>
+            <a:off x="6809078" y="5395873"/>
+            <a:ext cx="2394127" cy="382219"/>
+          </a:xfrm>
+          <a:prstGeom prst="roundRect">
+            <a:avLst>
+              <a:gd name="adj" fmla="val 6000"/>
+            </a:avLst>
+          </a:prstGeom>
+          <a:noFill/>
+          <a:ln w="9525">
+            <a:solidFill>
+              <a:srgbClr val="3A3A48"/>
+            </a:solidFill>
+            <a:prstDash val="dash"/>
+          </a:ln>
+          <a:effectLst/>
+        </p:spPr>
+        <p:style>
+          <a:lnRef idx="1">
+            <a:schemeClr val="accent1"/>
+          </a:lnRef>
+          <a:fillRef idx="3">
+            <a:schemeClr val="accent1"/>
+          </a:fillRef>
+          <a:effectRef idx="2">
+            <a:schemeClr val="accent1"/>
+          </a:effectRef>
+          <a:fontRef idx="minor">
+            <a:schemeClr val="lt1"/>
+          </a:fontRef>
+        </p:style>
+        <p:txBody>
+          <a:bodyPr rtlCol="0" anchor="ctr" wrap="square" lIns="25400" rIns="25400" tIns="25400" bIns="25400"/>
+          <a:lstStyle/>
+          <a:p>
+            <a:pPr algn="ctr"/>
+            <a:r>
+              <a:rPr sz="900" b="0">
+                <a:solidFill>
+                  <a:srgbClr val="4F4D47"/>
+                </a:solidFill>
+                <a:latin typeface="Inter"/>
+              </a:rPr>
+              <a:t>n/a</a:t>
+            </a:r>
+          </a:p>
+        </p:txBody>
+      </p:sp>
+      <p:sp>
+        <p:nvSpPr>
+          <p:cNvPr id="52" name="Rounded Rectangle 51"/>
+          <p:cNvSpPr/>
+          <p:nvPr/>
+        </p:nvSpPr>
+        <p:spPr>
+          <a:xfrm>
+            <a:off x="9235209" y="5395873"/>
+            <a:ext cx="2394127" cy="382219"/>
+          </a:xfrm>
+          <a:prstGeom prst="roundRect">
+            <a:avLst>
+              <a:gd name="adj" fmla="val 6000"/>
+            </a:avLst>
+          </a:prstGeom>
+          <a:noFill/>
+          <a:ln w="9525">
+            <a:solidFill>
+              <a:srgbClr val="3A3A48"/>
+            </a:solidFill>
+            <a:prstDash val="dash"/>
+          </a:ln>
+          <a:effectLst/>
+        </p:spPr>
+        <p:style>
+          <a:lnRef idx="1">
+            <a:schemeClr val="accent1"/>
+          </a:lnRef>
+          <a:fillRef idx="3">
+            <a:schemeClr val="accent1"/>
+          </a:fillRef>
+          <a:effectRef idx="2">
+            <a:schemeClr val="accent1"/>
+          </a:effectRef>
+          <a:fontRef idx="minor">
+            <a:schemeClr val="lt1"/>
+          </a:fontRef>
+        </p:style>
+        <p:txBody>
+          <a:bodyPr rtlCol="0" anchor="ctr" wrap="square" lIns="25400" rIns="25400" tIns="25400" bIns="25400"/>
+          <a:lstStyle/>
+          <a:p>
+            <a:pPr algn="ctr"/>
+            <a:r>
+              <a:rPr sz="900" b="0">
+                <a:solidFill>
+                  <a:srgbClr val="4F4D47"/>
+                </a:solidFill>
+                <a:latin typeface="Inter"/>
+              </a:rPr>
+              <a:t>n/a</a:t>
+            </a:r>
+          </a:p>
+        </p:txBody>
+      </p:sp>
+      <p:sp>
+        <p:nvSpPr>
+          <p:cNvPr id="53" name="TextBox 52"/>
+          <p:cNvSpPr txBox="1"/>
+          <p:nvPr/>
+        </p:nvSpPr>
+        <p:spPr>
+          <a:xfrm>
+            <a:off x="658368" y="5810096"/>
+            <a:ext cx="1207008" cy="382219"/>
+          </a:xfrm>
+          <a:prstGeom prst="rect">
+            <a:avLst/>
+          </a:prstGeom>
+          <a:noFill/>
+        </p:spPr>
+        <p:txBody>
+          <a:bodyPr wrap="square" anchor="ctr" lIns="0" rIns="0" tIns="0" bIns="0">
+            <a:spAutoFit/>
+          </a:bodyPr>
+          <a:lstStyle/>
+          <a:p>
+            <a:pPr algn="r"/>
+            <a:r>
+              <a:rPr sz="1150" b="1" i="0">
+                <a:solidFill>
+                  <a:srgbClr val="C9C6BF"/>
+                </a:solidFill>
+                <a:latin typeface="Inter"/>
+              </a:rPr>
+              <a:t>GPT-5.5</a:t>
+            </a:r>
+          </a:p>
+        </p:txBody>
+      </p:sp>
+      <p:sp>
+        <p:nvSpPr>
+          <p:cNvPr id="54" name="Rounded Rectangle 53"/>
+          <p:cNvSpPr/>
+          <p:nvPr/>
+        </p:nvSpPr>
+        <p:spPr>
+          <a:xfrm>
+            <a:off x="1956816" y="5810096"/>
+            <a:ext cx="2394127" cy="382219"/>
+          </a:xfrm>
+          <a:prstGeom prst="roundRect">
+            <a:avLst>
+              <a:gd name="adj" fmla="val 6000"/>
+            </a:avLst>
+          </a:prstGeom>
+          <a:noFill/>
+          <a:ln w="9525">
+            <a:solidFill>
+              <a:srgbClr val="3A3A48"/>
+            </a:solidFill>
+            <a:prstDash val="dash"/>
+          </a:ln>
+          <a:effectLst/>
+        </p:spPr>
+        <p:style>
+          <a:lnRef idx="1">
+            <a:schemeClr val="accent1"/>
+          </a:lnRef>
+          <a:fillRef idx="3">
+            <a:schemeClr val="accent1"/>
+          </a:fillRef>
+          <a:effectRef idx="2">
+            <a:schemeClr val="accent1"/>
+          </a:effectRef>
+          <a:fontRef idx="minor">
+            <a:schemeClr val="lt1"/>
+          </a:fontRef>
+        </p:style>
+        <p:txBody>
+          <a:bodyPr rtlCol="0" anchor="ctr" wrap="square" lIns="25400" rIns="25400" tIns="25400" bIns="25400"/>
+          <a:lstStyle/>
+          <a:p>
+            <a:pPr algn="ctr"/>
+            <a:r>
+              <a:rPr sz="900" b="0">
+                <a:solidFill>
+                  <a:srgbClr val="4F4D47"/>
+                </a:solidFill>
+                <a:latin typeface="Inter"/>
+              </a:rPr>
+              <a:t>n/a</a:t>
+            </a:r>
+          </a:p>
+        </p:txBody>
+      </p:sp>
+      <p:sp>
+        <p:nvSpPr>
+          <p:cNvPr id="55" name="Rounded Rectangle 54"/>
+          <p:cNvSpPr/>
+          <p:nvPr/>
+        </p:nvSpPr>
+        <p:spPr>
+          <a:xfrm>
+            <a:off x="4382947" y="5810096"/>
+            <a:ext cx="2394127" cy="382219"/>
+          </a:xfrm>
+          <a:prstGeom prst="roundRect">
+            <a:avLst>
+              <a:gd name="adj" fmla="val 6000"/>
+            </a:avLst>
+          </a:prstGeom>
+          <a:solidFill>
+            <a:srgbClr val="2B2712"/>
+          </a:solidFill>
+          <a:ln>
+            <a:noFill/>
+          </a:ln>
+          <a:effectLst/>
+        </p:spPr>
+        <p:style>
+          <a:lnRef idx="1">
+            <a:schemeClr val="accent1"/>
+          </a:lnRef>
+          <a:fillRef idx="3">
+            <a:schemeClr val="accent1"/>
+          </a:fillRef>
+          <a:effectRef idx="2">
+            <a:schemeClr val="accent1"/>
+          </a:effectRef>
+          <a:fontRef idx="minor">
+            <a:schemeClr val="lt1"/>
+          </a:fontRef>
+        </p:style>
+        <p:txBody>
+          <a:bodyPr rtlCol="0" anchor="ctr" wrap="square" lIns="25400" rIns="25400" tIns="25400" bIns="25400"/>
+          <a:lstStyle/>
+          <a:p>
+            <a:pPr algn="ctr"/>
+            <a:r>
+              <a:rPr sz="1300" b="1">
+                <a:solidFill>
+                  <a:srgbClr val="F5DC5E"/>
+                </a:solidFill>
+                <a:latin typeface="Inter"/>
+              </a:rPr>
+              <a:t>●</a:t>
+            </a:r>
+          </a:p>
+        </p:txBody>
+      </p:sp>
+      <p:sp>
+        <p:nvSpPr>
+          <p:cNvPr id="56" name="Rounded Rectangle 55"/>
+          <p:cNvSpPr/>
+          <p:nvPr/>
+        </p:nvSpPr>
+        <p:spPr>
+          <a:xfrm>
+            <a:off x="6809078" y="5810096"/>
+            <a:ext cx="2394127" cy="382219"/>
+          </a:xfrm>
+          <a:prstGeom prst="roundRect">
+            <a:avLst>
+              <a:gd name="adj" fmla="val 6000"/>
+            </a:avLst>
+          </a:prstGeom>
+          <a:solidFill>
+            <a:srgbClr val="C97C88"/>
+          </a:solidFill>
+          <a:ln>
+            <a:noFill/>
+          </a:ln>
+          <a:effectLst/>
+        </p:spPr>
+        <p:style>
+          <a:lnRef idx="1">
+            <a:schemeClr val="accent1"/>
+          </a:lnRef>
+          <a:fillRef idx="3">
+            <a:schemeClr val="accent1"/>
+          </a:fillRef>
+          <a:effectRef idx="2">
+            <a:schemeClr val="accent1"/>
+          </a:effectRef>
+          <a:fontRef idx="minor">
+            <a:schemeClr val="lt1"/>
+          </a:fontRef>
+        </p:style>
+        <p:txBody>
+          <a:bodyPr rtlCol="0" anchor="ctr" wrap="square" lIns="25400" rIns="25400" tIns="25400" bIns="25400"/>
+          <a:lstStyle/>
+          <a:p>
+            <a:pPr algn="ctr"/>
+            <a:r>
+              <a:rPr sz="1500" b="1">
+                <a:solidFill>
+                  <a:srgbClr val="08080C"/>
+                </a:solidFill>
+                <a:latin typeface="JetBrains Mono"/>
+              </a:rPr>
+              <a:t>8.0</a:t>
+            </a:r>
+          </a:p>
+        </p:txBody>
+      </p:sp>
+      <p:sp>
+        <p:nvSpPr>
+          <p:cNvPr id="57" name="Rounded Rectangle 56"/>
+          <p:cNvSpPr/>
+          <p:nvPr/>
+        </p:nvSpPr>
+        <p:spPr>
+          <a:xfrm>
+            <a:off x="9235209" y="5810096"/>
+            <a:ext cx="2394127" cy="382219"/>
+          </a:xfrm>
+          <a:prstGeom prst="roundRect">
+            <a:avLst>
+              <a:gd name="adj" fmla="val 6000"/>
+            </a:avLst>
+          </a:prstGeom>
+          <a:solidFill>
+            <a:srgbClr val="DE9FA9"/>
+          </a:solidFill>
+          <a:ln>
+            <a:noFill/>
+          </a:ln>
+          <a:effectLst/>
+        </p:spPr>
+        <p:style>
+          <a:lnRef idx="1">
+            <a:schemeClr val="accent1"/>
+          </a:lnRef>
+          <a:fillRef idx="3">
+            <a:schemeClr val="accent1"/>
+          </a:fillRef>
+          <a:effectRef idx="2">
+            <a:schemeClr val="accent1"/>
+          </a:effectRef>
+          <a:fontRef idx="minor">
+            <a:schemeClr val="lt1"/>
+          </a:fontRef>
+        </p:style>
+        <p:txBody>
+          <a:bodyPr rtlCol="0" anchor="ctr" wrap="square" lIns="25400" rIns="25400" tIns="25400" bIns="25400"/>
+          <a:lstStyle/>
+          <a:p>
+            <a:pPr algn="ctr"/>
+            <a:r>
+              <a:rPr sz="1500" b="1">
+                <a:solidFill>
+                  <a:srgbClr val="08080C"/>
+                </a:solidFill>
+                <a:latin typeface="JetBrains Mono"/>
+              </a:rPr>
+              <a:t>9.0</a:t>
+            </a:r>
+          </a:p>
+        </p:txBody>
+      </p:sp>
+      <p:sp>
+        <p:nvSpPr>
+          <p:cNvPr id="58" name="Rounded Rectangle 57"/>
+          <p:cNvSpPr/>
+          <p:nvPr/>
+        </p:nvSpPr>
+        <p:spPr>
+          <a:xfrm>
+            <a:off x="658368" y="6352335"/>
+            <a:ext cx="685800" cy="82296"/>
+          </a:xfrm>
+          <a:prstGeom prst="roundRect">
+            <a:avLst>
+              <a:gd name="adj" fmla="val 50000"/>
+            </a:avLst>
+          </a:prstGeom>
+          <a:gradFill rotWithShape="1">
+            <a:gsLst>
+              <a:gs pos="0">
+                <a:srgbClr val="2A1015"/>
+              </a:gs>
+              <a:gs pos="100000">
+                <a:srgbClr val="F3C2CA"/>
+              </a:gs>
+            </a:gsLst>
+            <a:lin scaled="0" ang="0"/>
+          </a:gradFill>
+          <a:ln>
+            <a:noFill/>
+          </a:ln>
+          <a:effectLst/>
+        </p:spPr>
+        <p:style>
+          <a:lnRef idx="1">
+            <a:schemeClr val="accent1"/>
+          </a:lnRef>
+          <a:fillRef idx="3">
+            <a:schemeClr val="accent1"/>
+          </a:fillRef>
+          <a:effectRef idx="2">
+            <a:schemeClr val="accent1"/>
+          </a:effectRef>
+          <a:fontRef idx="minor">
+            <a:schemeClr val="lt1"/>
+          </a:fontRef>
+        </p:style>
+        <p:txBody>
+          <a:bodyPr rtlCol="0" anchor="ctr"/>
+          <a:lstStyle/>
+          <a:p>
+            <a:pPr algn="ctr"/>
+          </a:p>
+        </p:txBody>
+      </p:sp>
+      <p:sp>
+        <p:nvSpPr>
+          <p:cNvPr id="59" name="TextBox 58"/>
+          <p:cNvSpPr txBox="1"/>
+          <p:nvPr/>
+        </p:nvSpPr>
+        <p:spPr>
+          <a:xfrm>
+            <a:off x="1417320" y="6315759"/>
+            <a:ext cx="3291840" cy="182880"/>
+          </a:xfrm>
+          <a:prstGeom prst="rect">
+            <a:avLst/>
+          </a:prstGeom>
+          <a:noFill/>
+        </p:spPr>
+        <p:txBody>
+          <a:bodyPr wrap="square" anchor="t" lIns="0" rIns="0" tIns="0" bIns="0">
+            <a:spAutoFit/>
+          </a:bodyPr>
+          <a:lstStyle/>
+          <a:p>
+            <a:pPr algn="l"/>
+            <a:r>
+              <a:rPr sz="1050" b="0" i="0">
+                <a:solidFill>
+                  <a:srgbClr val="C9C6BF"/>
+                </a:solidFill>
+                <a:latin typeface="Inter"/>
+              </a:rPr>
+              <a:t>code quality, 0-10, absolute scale</a:t>
+            </a:r>
+          </a:p>
+        </p:txBody>
+      </p:sp>
+      <p:sp>
+        <p:nvSpPr>
+          <p:cNvPr id="60" name="Oval 59"/>
+          <p:cNvSpPr/>
+          <p:nvPr/>
+        </p:nvSpPr>
+        <p:spPr>
+          <a:xfrm>
+            <a:off x="3934663" y="6352335"/>
+            <a:ext cx="82296" cy="82296"/>
+          </a:xfrm>
+          <a:prstGeom prst="ellipse">
+            <a:avLst/>
+          </a:prstGeom>
+          <a:solidFill>
+            <a:srgbClr val="F5DC5E"/>
+          </a:solidFill>
+          <a:ln>
+            <a:noFill/>
+          </a:ln>
+          <a:effectLst/>
+        </p:spPr>
+        <p:style>
+          <a:lnRef idx="1">
+            <a:schemeClr val="accent1"/>
+          </a:lnRef>
+          <a:fillRef idx="3">
+            <a:schemeClr val="accent1"/>
+          </a:fillRef>
+          <a:effectRef idx="2">
+            <a:schemeClr val="accent1"/>
+          </a:effectRef>
+          <a:fontRef idx="minor">
+            <a:schemeClr val="lt1"/>
+          </a:fontRef>
+        </p:style>
+        <p:txBody>
+          <a:bodyPr rtlCol="0" anchor="ctr"/>
+          <a:lstStyle/>
+          <a:p>
+            <a:pPr algn="ctr"/>
+          </a:p>
+        </p:txBody>
+      </p:sp>
+      <p:sp>
+        <p:nvSpPr>
+          <p:cNvPr id="61" name="TextBox 60"/>
+          <p:cNvSpPr txBox="1"/>
+          <p:nvPr/>
+        </p:nvSpPr>
+        <p:spPr>
+          <a:xfrm>
+            <a:off x="4112971" y="6315759"/>
+            <a:ext cx="3291840" cy="182880"/>
+          </a:xfrm>
+          <a:prstGeom prst="rect">
+            <a:avLst/>
+          </a:prstGeom>
+          <a:noFill/>
+        </p:spPr>
+        <p:txBody>
+          <a:bodyPr wrap="square" anchor="t" lIns="0" rIns="0" tIns="0" bIns="0">
+            <a:spAutoFit/>
+          </a:bodyPr>
+          <a:lstStyle/>
+          <a:p>
+            <a:pPr algn="l"/>
+            <a:r>
+              <a:rPr sz="1050" b="0" i="0">
+                <a:solidFill>
+                  <a:srgbClr val="C9C6BF"/>
+                </a:solidFill>
+                <a:latin typeface="Inter"/>
+              </a:rPr>
+              <a:t>real reachable AI/logic bug found</a:t>
+            </a:r>
+          </a:p>
+        </p:txBody>
+      </p:sp>
+      <p:sp>
+        <p:nvSpPr>
+          <p:cNvPr id="62" name="Rounded Rectangle 61"/>
+          <p:cNvSpPr/>
+          <p:nvPr/>
+        </p:nvSpPr>
+        <p:spPr>
+          <a:xfrm>
+            <a:off x="6541617" y="6334047"/>
+            <a:ext cx="128016" cy="128016"/>
+          </a:xfrm>
+          <a:prstGeom prst="roundRect">
+            <a:avLst>
+              <a:gd name="adj" fmla="val 25000"/>
+            </a:avLst>
+          </a:prstGeom>
+          <a:solidFill>
+            <a:srgbClr val="5A111C"/>
+          </a:solidFill>
+          <a:ln w="12700">
+            <a:solidFill>
+              <a:srgbClr val="F56B8C"/>
+            </a:solidFill>
+            <a:prstDash val="dash"/>
+          </a:ln>
+          <a:effectLst/>
+        </p:spPr>
+        <p:style>
+          <a:lnRef idx="1">
+            <a:schemeClr val="accent1"/>
+          </a:lnRef>
+          <a:fillRef idx="3">
+            <a:schemeClr val="accent1"/>
+          </a:fillRef>
+          <a:effectRef idx="2">
+            <a:schemeClr val="accent1"/>
+          </a:effectRef>
+          <a:fontRef idx="minor">
+            <a:schemeClr val="lt1"/>
+          </a:fontRef>
+        </p:style>
+        <p:txBody>
+          <a:bodyPr rtlCol="0" anchor="ctr"/>
+          <a:lstStyle/>
+          <a:p>
+            <a:pPr algn="ctr"/>
+          </a:p>
+        </p:txBody>
+      </p:sp>
+      <p:sp>
+        <p:nvSpPr>
+          <p:cNvPr id="63" name="TextBox 62"/>
+          <p:cNvSpPr txBox="1"/>
+          <p:nvPr/>
+        </p:nvSpPr>
+        <p:spPr>
+          <a:xfrm>
+            <a:off x="6742785" y="6315759"/>
+            <a:ext cx="3291840" cy="182880"/>
+          </a:xfrm>
+          <a:prstGeom prst="rect">
+            <a:avLst/>
+          </a:prstGeom>
+          <a:noFill/>
+        </p:spPr>
+        <p:txBody>
+          <a:bodyPr wrap="square" anchor="t" lIns="0" rIns="0" tIns="0" bIns="0">
+            <a:spAutoFit/>
+          </a:bodyPr>
+          <a:lstStyle/>
+          <a:p>
+            <a:pPr algn="l"/>
+            <a:r>
+              <a:rPr sz="1050" b="0" i="0">
+                <a:solidFill>
+                  <a:srgbClr val="C9C6BF"/>
+                </a:solidFill>
+                <a:latin typeface="Inter"/>
+              </a:rPr>
+              <a:t>disqualified, doesn't run</a:t>
+            </a:r>
+          </a:p>
+        </p:txBody>
+      </p:sp>
+      <p:sp>
+        <p:nvSpPr>
+          <p:cNvPr id="64" name="Rounded Rectangle 63"/>
+          <p:cNvSpPr/>
+          <p:nvPr/>
+        </p:nvSpPr>
+        <p:spPr>
+          <a:xfrm>
+            <a:off x="8644736" y="6334047"/>
+            <a:ext cx="128016" cy="128016"/>
+          </a:xfrm>
+          <a:prstGeom prst="roundRect">
+            <a:avLst>
+              <a:gd name="adj" fmla="val 25000"/>
+            </a:avLst>
+          </a:prstGeom>
+          <a:solidFill>
+            <a:srgbClr val="3A1520"/>
+          </a:solidFill>
+          <a:ln>
+            <a:noFill/>
+          </a:ln>
+          <a:effectLst/>
+        </p:spPr>
+        <p:style>
+          <a:lnRef idx="1">
+            <a:schemeClr val="accent1"/>
+          </a:lnRef>
+          <a:fillRef idx="3">
+            <a:schemeClr val="accent1"/>
+          </a:fillRef>
+          <a:effectRef idx="2">
+            <a:schemeClr val="accent1"/>
+          </a:effectRef>
+          <a:fontRef idx="minor">
+            <a:schemeClr val="lt1"/>
+          </a:fontRef>
+        </p:style>
+        <p:txBody>
+          <a:bodyPr rtlCol="0" anchor="ctr"/>
+          <a:lstStyle/>
+          <a:p>
+            <a:pPr algn="ctr"/>
+          </a:p>
+        </p:txBody>
+      </p:sp>
+      <p:sp>
+        <p:nvSpPr>
+          <p:cNvPr id="65" name="TextBox 64"/>
+          <p:cNvSpPr txBox="1"/>
+          <p:nvPr/>
+        </p:nvSpPr>
+        <p:spPr>
+          <a:xfrm>
+            <a:off x="8845904" y="6315759"/>
+            <a:ext cx="3291840" cy="182880"/>
+          </a:xfrm>
+          <a:prstGeom prst="rect">
+            <a:avLst/>
+          </a:prstGeom>
+          <a:noFill/>
+        </p:spPr>
+        <p:txBody>
+          <a:bodyPr wrap="square" anchor="t" lIns="0" rIns="0" tIns="0" bIns="0">
+            <a:spAutoFit/>
+          </a:bodyPr>
+          <a:lstStyle/>
+          <a:p>
+            <a:pPr algn="l"/>
+            <a:r>
+              <a:rPr sz="1050" b="0" i="0">
+                <a:solidFill>
+                  <a:srgbClr val="C9C6BF"/>
+                </a:solidFill>
+                <a:latin typeface="Inter"/>
+              </a:rPr>
+              <a:t>failed, not reviewed</a:t>
+            </a:r>
+          </a:p>
+        </p:txBody>
+      </p:sp>
+      <p:sp>
+        <p:nvSpPr>
+          <p:cNvPr id="66" name="Rounded Rectangle 65"/>
+          <p:cNvSpPr/>
+          <p:nvPr/>
+        </p:nvSpPr>
+        <p:spPr>
+          <a:xfrm>
+            <a:off x="10418672" y="6334047"/>
+            <a:ext cx="128016" cy="128016"/>
+          </a:xfrm>
+          <a:prstGeom prst="roundRect">
+            <a:avLst>
+              <a:gd name="adj" fmla="val 25000"/>
+            </a:avLst>
+          </a:prstGeom>
+          <a:solidFill>
+            <a:srgbClr val="2B2712"/>
+          </a:solidFill>
+          <a:ln>
+            <a:noFill/>
+          </a:ln>
+          <a:effectLst/>
+        </p:spPr>
+        <p:style>
+          <a:lnRef idx="1">
+            <a:schemeClr val="accent1"/>
+          </a:lnRef>
+          <a:fillRef idx="3">
+            <a:schemeClr val="accent1"/>
+          </a:fillRef>
+          <a:effectRef idx="2">
+            <a:schemeClr val="accent1"/>
+          </a:effectRef>
+          <a:fontRef idx="minor">
+            <a:schemeClr val="lt1"/>
+          </a:fontRef>
+        </p:style>
+        <p:txBody>
+          <a:bodyPr rtlCol="0" anchor="ctr"/>
+          <a:lstStyle/>
+          <a:p>
+            <a:pPr algn="ctr"/>
+          </a:p>
+        </p:txBody>
+      </p:sp>
+      <p:sp>
+        <p:nvSpPr>
+          <p:cNvPr id="67" name="TextBox 66"/>
+          <p:cNvSpPr txBox="1"/>
+          <p:nvPr/>
+        </p:nvSpPr>
+        <p:spPr>
+          <a:xfrm>
+            <a:off x="10619840" y="6315759"/>
+            <a:ext cx="3291840" cy="182880"/>
+          </a:xfrm>
+          <a:prstGeom prst="rect">
+            <a:avLst/>
+          </a:prstGeom>
+          <a:noFill/>
+        </p:spPr>
+        <p:txBody>
+          <a:bodyPr wrap="square" anchor="t" lIns="0" rIns="0" tIns="0" bIns="0">
+            <a:spAutoFit/>
+          </a:bodyPr>
+          <a:lstStyle/>
+          <a:p>
+            <a:pPr algn="l"/>
+            <a:r>
+              <a:rPr sz="1050" b="0" i="0">
+                <a:solidFill>
+                  <a:srgbClr val="C9C6BF"/>
+                </a:solidFill>
+                <a:latin typeface="Inter"/>
+              </a:rPr>
+              <a:t>killed early, not reviewed</a:t>
+            </a:r>
+          </a:p>
+        </p:txBody>
+      </p:sp>
+      <p:sp>
+        <p:nvSpPr>
+          <p:cNvPr id="68" name="Rounded Rectangle 67"/>
+          <p:cNvSpPr/>
+          <p:nvPr/>
+        </p:nvSpPr>
+        <p:spPr>
+          <a:xfrm>
+            <a:off x="658368" y="6473952"/>
+            <a:ext cx="146304" cy="146304"/>
+          </a:xfrm>
+          <a:prstGeom prst="roundRect">
+            <a:avLst>
+              <a:gd name="adj" fmla="val 30000"/>
+            </a:avLst>
+          </a:prstGeom>
+          <a:solidFill>
+            <a:srgbClr val="8A1224"/>
+          </a:solidFill>
+          <a:ln>
+            <a:noFill/>
+          </a:ln>
+          <a:effectLst/>
+        </p:spPr>
+        <p:style>
+          <a:lnRef idx="1">
+            <a:schemeClr val="accent1"/>
+          </a:lnRef>
+          <a:fillRef idx="3">
+            <a:schemeClr val="accent1"/>
+          </a:fillRef>
+          <a:effectRef idx="2">
+            <a:schemeClr val="accent1"/>
+          </a:effectRef>
+          <a:fontRef idx="minor">
+            <a:schemeClr val="lt1"/>
+          </a:fontRef>
+        </p:style>
+        <p:txBody>
+          <a:bodyPr rtlCol="0" anchor="ctr" wrap="square" lIns="25400" rIns="25400" tIns="25400" bIns="25400"/>
+          <a:lstStyle/>
+          <a:p>
+            <a:pPr algn="ctr"/>
+            <a:r>
+              <a:rPr sz="600" b="1">
+                <a:solidFill>
+                  <a:srgbClr val="E8E6E1"/>
+                </a:solidFill>
+                <a:latin typeface="Inter"/>
+              </a:rPr>
+              <a:t>4D</a:t>
+            </a:r>
+          </a:p>
+        </p:txBody>
+      </p:sp>
+      <p:sp>
+        <p:nvSpPr>
+          <p:cNvPr id="69" name="TextBox 68"/>
+          <p:cNvSpPr txBox="1"/>
+          <p:nvPr/>
+        </p:nvSpPr>
+        <p:spPr>
+          <a:xfrm>
+            <a:off x="877824" y="6460236"/>
+            <a:ext cx="8229600" cy="182880"/>
+          </a:xfrm>
+          <a:prstGeom prst="rect">
+            <a:avLst/>
+          </a:prstGeom>
+          <a:noFill/>
+        </p:spPr>
+        <p:txBody>
+          <a:bodyPr wrap="square" anchor="t" lIns="0" rIns="0" tIns="0" bIns="0">
+            <a:spAutoFit/>
+          </a:bodyPr>
+          <a:lstStyle/>
+          <a:p>
+            <a:pPr algn="l"/>
+            <a:r>
+              <a:rPr sz="1050" b="0" i="0">
+                <a:solidFill>
+                  <a:srgbClr val="4F4D47"/>
+                </a:solidFill>
+                <a:latin typeface="Inter"/>
+              </a:rPr>
+              <a:t>4D Tic-Tac-Toe Benchmark · analysis/quality_scores.csv</a:t>
+            </a:r>
+          </a:p>
+        </p:txBody>
+      </p:sp>
     </p:spTree>
   </p:cSld>
   <p:clrMapOvr>

</xml_diff>